<commit_message>
vault backup: 2026-09-08 13:46:24
</commit_message>
<xml_diff>
--- a/포트폴리오_정상윤_2026_v2.pptx
+++ b/포트폴리오_정상윤_2026_v2.pptx
@@ -15,6 +15,7 @@
     <p:sldId id="260" r:id="rId6"/>
     <p:sldId id="261" r:id="rId7"/>
     <p:sldId id="262" r:id="rId8"/>
+    <p:sldId id="266" r:id="rId16"/>
     <p:sldId id="263" r:id="rId9"/>
     <p:sldId id="264" r:id="rId10"/>
   </p:sldIdLst>
@@ -1463,6 +1464,156 @@
 </p:sld>
 </file>
 
+<file path=ppt/slides/slide10.xml><?xml version="1.0" encoding="utf-8"?>
+<p:sld xmlns:a="http://schemas.openxmlformats.org/drawingml/2006/main" xmlns:r="http://schemas.openxmlformats.org/officeDocument/2006/relationships" xmlns:p="http://schemas.openxmlformats.org/presentationml/2006/main">
+  <p:cSld name="Slide 9">
+    <p:bg>
+      <p:bgPr>
+        <a:solidFill>
+          <a:srgbClr val="1E2761"/>
+        </a:solidFill>
+        <a:effectLst/>
+      </p:bgPr>
+    </p:bg>
+    <p:spTree>
+      <p:nvGrpSpPr>
+        <p:cNvPr id="1" name=""/>
+        <p:cNvGrpSpPr/>
+        <p:nvPr/>
+      </p:nvGrpSpPr>
+      <p:grpSpPr>
+        <a:xfrm>
+          <a:off x="0" y="0"/>
+          <a:ext cx="0" cy="0"/>
+          <a:chOff x="0" y="0"/>
+          <a:chExt cx="0" cy="0"/>
+        </a:xfrm>
+      </p:grpSpPr>
+      <p:sp>
+        <p:nvSpPr>
+          <p:cNvPr id="2" name="Text 0"/>
+          <p:cNvSpPr/>
+          <p:nvPr/>
+        </p:nvSpPr>
+        <p:spPr>
+          <a:xfrm>
+            <a:off x="548640" y="2286000"/>
+            <a:ext cx="7315200" cy="365760"/>
+          </a:xfrm>
+          <a:prstGeom prst="rect">
+            <a:avLst/>
+          </a:prstGeom>
+          <a:noFill/>
+          <a:ln/>
+        </p:spPr>
+        <p:txBody>
+          <a:bodyPr wrap="square" rtlCol="0" anchor="ctr"/>
+          <a:lstStyle/>
+          <a:p>
+            <a:pPr marL="0" indent="0">
+              <a:buNone/>
+            </a:pPr>
+            <a:r>
+              <a:rPr lang="en-US" sz="1300" b="1" kern="0" spc="200" dirty="0">
+                <a:solidFill>
+                  <a:srgbClr val="CADCFC"/>
+                </a:solidFill>
+                <a:latin typeface="맑은 고딕" pitchFamily="34" charset="0"/>
+                <a:ea typeface="맑은 고딕" pitchFamily="34" charset="-122"/>
+                <a:cs typeface="맑은 고딕" pitchFamily="34" charset="-120"/>
+              </a:rPr>
+              <a:t>THANK YOU</a:t>
+            </a:r>
+            <a:endParaRPr lang="en-US" sz="1300" dirty="0"/>
+          </a:p>
+        </p:txBody>
+      </p:sp>
+      <p:sp>
+        <p:nvSpPr>
+          <p:cNvPr id="3" name="Text 1"/>
+          <p:cNvSpPr/>
+          <p:nvPr/>
+        </p:nvSpPr>
+        <p:spPr>
+          <a:xfrm>
+            <a:off x="548640" y="2697480"/>
+            <a:ext cx="9144000" cy="1188720"/>
+          </a:xfrm>
+          <a:prstGeom prst="rect">
+            <a:avLst/>
+          </a:prstGeom>
+          <a:noFill/>
+          <a:ln/>
+        </p:spPr>
+        <p:txBody>
+          <a:bodyPr wrap="square" rtlCol="0" anchor="ctr"/>
+          <a:lstStyle/>
+          <a:p>
+            <a:pPr marL="0" indent="0">
+              <a:buNone/>
+            </a:pPr>
+            <a:r>
+              <a:rPr lang="en-US" sz="4000" b="1" dirty="0">
+                <a:solidFill>
+                  <a:srgbClr val="FFFFFF"/>
+                </a:solidFill>
+                <a:latin typeface="맑은 고딕" pitchFamily="34" charset="0"/>
+                <a:ea typeface="맑은 고딕" pitchFamily="34" charset="-122"/>
+                <a:cs typeface="맑은 고딕" pitchFamily="34" charset="-120"/>
+              </a:rPr>
+              <a:t>감사합니다</a:t>
+            </a:r>
+            <a:endParaRPr lang="en-US" sz="4000" dirty="0"/>
+          </a:p>
+        </p:txBody>
+      </p:sp>
+      <p:sp>
+        <p:nvSpPr>
+          <p:cNvPr id="4" name="Text 2"/>
+          <p:cNvSpPr/>
+          <p:nvPr/>
+        </p:nvSpPr>
+        <p:spPr>
+          <a:xfrm>
+            <a:off x="548640" y="3749040"/>
+            <a:ext cx="8229600" cy="457200"/>
+          </a:xfrm>
+          <a:prstGeom prst="rect">
+            <a:avLst/>
+          </a:prstGeom>
+          <a:noFill/>
+          <a:ln/>
+        </p:spPr>
+        <p:txBody>
+          <a:bodyPr wrap="square" rtlCol="0" anchor="ctr"/>
+          <a:lstStyle/>
+          <a:p>
+            <a:pPr marL="0" indent="0">
+              <a:buNone/>
+            </a:pPr>
+            <a:r>
+              <a:rPr lang="en-US" sz="1800" dirty="0">
+                <a:solidFill>
+                  <a:srgbClr val="CADCFC"/>
+                </a:solidFill>
+                <a:latin typeface="맑은 고딕" pitchFamily="34" charset="0"/>
+                <a:ea typeface="맑은 고딕" pitchFamily="34" charset="-122"/>
+                <a:cs typeface="맑은 고딕" pitchFamily="34" charset="-120"/>
+              </a:rPr>
+              <a:t>정상윤</a:t>
+            </a:r>
+            <a:endParaRPr lang="en-US" sz="1800" dirty="0"/>
+          </a:p>
+        </p:txBody>
+      </p:sp>
+    </p:spTree>
+  </p:cSld>
+  <p:clrMapOvr>
+    <a:masterClrMapping/>
+  </p:clrMapOvr>
+</p:sld>
+</file>
+
 <file path=ppt/slides/slide2.xml><?xml version="1.0" encoding="utf-8"?>
 <p:sld xmlns:a="http://schemas.openxmlformats.org/drawingml/2006/main" xmlns:r="http://schemas.openxmlformats.org/officeDocument/2006/relationships" xmlns:p="http://schemas.openxmlformats.org/presentationml/2006/main">
   <p:cSld name="Slide 2">
@@ -4783,7 +4934,7 @@
                 <a:ea typeface="맑은 고딕" pitchFamily="34" charset="-122"/>
                 <a:cs typeface="맑은 고딕" pitchFamily="34" charset="-120"/>
               </a:rPr>
-              <a:t>03  PROJECT 1/3</a:t>
+              <a:t>03  PROJECT 1/4</a:t>
             </a:r>
             <a:endParaRPr lang="en-US" sz="1100" dirty="0"/>
           </a:p>
@@ -5935,7 +6086,7 @@
                 <a:ea typeface="맑은 고딕" pitchFamily="34" charset="-122"/>
                 <a:cs typeface="맑은 고딕" pitchFamily="34" charset="-120"/>
               </a:rPr>
-              <a:t>03  PROJECT 2/3</a:t>
+              <a:t>03  PROJECT 2/4</a:t>
             </a:r>
             <a:endParaRPr lang="en-US" sz="1100" dirty="0"/>
           </a:p>
@@ -7087,7 +7238,7 @@
                 <a:ea typeface="맑은 고딕" pitchFamily="34" charset="-122"/>
                 <a:cs typeface="맑은 고딕" pitchFamily="34" charset="-120"/>
               </a:rPr>
-              <a:t>03  PROJECT 3/3</a:t>
+              <a:t>03  PROJECT 3/4</a:t>
             </a:r>
             <a:endParaRPr lang="en-US" sz="1100" dirty="0"/>
           </a:p>
@@ -8176,6 +8327,482 @@
 </file>
 
 <file path=ppt/slides/slide8.xml><?xml version="1.0" encoding="utf-8"?>
+<p:sld xmlns:a="http://schemas.openxmlformats.org/drawingml/2006/main" xmlns:r="http://schemas.openxmlformats.org/officeDocument/2006/relationships" xmlns:p="http://schemas.openxmlformats.org/presentationml/2006/main">
+  <p:cSld name="Slide 7">
+    <p:bg>
+      <p:bgPr>
+        <a:solidFill>
+          <a:srgbClr val="FFFFFF"/>
+        </a:solidFill>
+        <a:effectLst/>
+      </p:bgPr>
+    </p:bg>
+    <p:spTree>
+      <p:nvGrpSpPr>
+        <p:cNvPr id="1" name=""/>
+        <p:cNvGrpSpPr/>
+        <p:nvPr/>
+      </p:nvGrpSpPr>
+      <p:grpSpPr>
+        <a:xfrm>
+          <a:off x="0" y="0"/>
+          <a:ext cx="0" cy="0"/>
+          <a:chOff x="0" y="0"/>
+          <a:chExt cx="0" cy="0"/>
+        </a:xfrm>
+      </p:grpSpPr>
+      <p:sp>
+        <p:nvSpPr>
+          <p:cNvPr id="2" name="Shape 0"/>
+          <p:cNvSpPr/>
+          <p:nvPr/>
+        </p:nvSpPr>
+        <p:spPr>
+          <a:xfrm>
+            <a:off x="0" y="0"/>
+            <a:ext cx="12191695" cy="914400"/>
+          </a:xfrm>
+          <a:prstGeom prst="rect">
+            <a:avLst/>
+          </a:prstGeom>
+          <a:solidFill>
+            <a:srgbClr val="1E2761"/>
+          </a:solidFill>
+          <a:ln/>
+        </p:spPr>
+        <p:txBody>
+          <a:bodyPr/>
+          <a:lstStyle/>
+          <a:p>
+            <a:endParaRPr lang="ko-KR" altLang="en-US"/>
+          </a:p>
+        </p:txBody>
+      </p:sp>
+      <p:sp>
+        <p:nvSpPr>
+          <p:cNvPr id="3" name="Text 1"/>
+          <p:cNvSpPr/>
+          <p:nvPr/>
+        </p:nvSpPr>
+        <p:spPr>
+          <a:xfrm>
+            <a:off x="548640" y="164592"/>
+            <a:ext cx="1371600" cy="320040"/>
+          </a:xfrm>
+          <a:prstGeom prst="rect">
+            <a:avLst/>
+          </a:prstGeom>
+          <a:noFill/>
+          <a:ln/>
+        </p:spPr>
+        <p:txBody>
+          <a:bodyPr wrap="square" rtlCol="0" anchor="ctr"/>
+          <a:lstStyle/>
+          <a:p>
+            <a:pPr marL="0" indent="0">
+              <a:buNone/>
+            </a:pPr>
+            <a:r>
+              <a:rPr lang="en-US" sz="1100" b="1" kern="0" spc="100" dirty="0">
+                <a:solidFill>
+                  <a:srgbClr val="CADCFC"/>
+                </a:solidFill>
+                <a:latin typeface="맑은 고딕" pitchFamily="34" charset="0"/>
+                <a:ea typeface="맑은 고딕" pitchFamily="34" charset="-122"/>
+                <a:cs typeface="맑은 고딕" pitchFamily="34" charset="-120"/>
+              </a:rPr>
+              <a:t>03  PROJECT 4/4</a:t>
+            </a:r>
+            <a:endParaRPr lang="en-US" sz="1100" dirty="0"/>
+          </a:p>
+        </p:txBody>
+      </p:sp>
+      <p:sp>
+        <p:nvSpPr>
+          <p:cNvPr id="4" name="Text 2"/>
+          <p:cNvSpPr/>
+          <p:nvPr/>
+        </p:nvSpPr>
+        <p:spPr>
+          <a:xfrm>
+            <a:off x="548640" y="384048"/>
+            <a:ext cx="10058400" cy="502920"/>
+          </a:xfrm>
+          <a:prstGeom prst="rect">
+            <a:avLst/>
+          </a:prstGeom>
+          <a:noFill/>
+          <a:ln/>
+        </p:spPr>
+        <p:txBody>
+          <a:bodyPr wrap="square" rtlCol="0" anchor="ctr"/>
+          <a:lstStyle/>
+          <a:p>
+            <a:pPr marL="0" indent="0">
+              <a:buNone/>
+            </a:pPr>
+            <a:r>
+              <a:rPr lang="en-US" sz="2400" b="1" dirty="0">
+                <a:solidFill>
+                  <a:srgbClr val="FFFFFF"/>
+                </a:solidFill>
+                <a:latin typeface="맑은 고딕" pitchFamily="34" charset="0"/>
+                <a:ea typeface="맑은 고딕" pitchFamily="34" charset="-122"/>
+                <a:cs typeface="맑은 고딕" pitchFamily="34" charset="-120"/>
+              </a:rPr>
+              <a:t>대표 프로젝트</a:t>
+            </a:r>
+            <a:endParaRPr lang="en-US" sz="2400" dirty="0"/>
+          </a:p>
+        </p:txBody>
+      </p:sp>
+      <p:sp>
+        <p:nvSpPr>
+          <p:cNvPr id="5" name="Shape 3"/>
+          <p:cNvSpPr/>
+          <p:nvPr/>
+        </p:nvSpPr>
+        <p:spPr>
+          <a:xfrm>
+            <a:off x="548640" y="1188720"/>
+            <a:ext cx="11094415" cy="5166360"/>
+          </a:xfrm>
+          <a:prstGeom prst="roundRect">
+            <a:avLst>
+              <a:gd name="adj" fmla="val 2099"/>
+            </a:avLst>
+          </a:prstGeom>
+          <a:solidFill>
+            <a:srgbClr val="F1F5FC"/>
+          </a:solidFill>
+          <a:ln w="12700">
+            <a:solidFill>
+              <a:srgbClr val="D8E3F5"/>
+            </a:solidFill>
+            <a:prstDash val="solid"/>
+          </a:ln>
+          <a:effectLst>
+            <a:outerShdw blurRad="76200" dist="25400" dir="5400000" algn="bl" rotWithShape="0">
+              <a:srgbClr val="1E2761">
+                <a:alpha val="12000"/>
+              </a:srgbClr>
+            </a:outerShdw>
+          </a:effectLst>
+        </p:spPr>
+        <p:txBody>
+          <a:bodyPr/>
+          <a:lstStyle/>
+          <a:p>
+            <a:endParaRPr lang="ko-KR" altLang="en-US"/>
+          </a:p>
+        </p:txBody>
+      </p:sp>
+      <p:sp>
+        <p:nvSpPr>
+          <p:cNvPr id="6" name="Shape 4"/>
+          <p:cNvSpPr/>
+          <p:nvPr/>
+        </p:nvSpPr>
+        <p:spPr>
+          <a:xfrm>
+            <a:off x="548640" y="1188720"/>
+            <a:ext cx="11094415" cy="457200"/>
+          </a:xfrm>
+          <a:prstGeom prst="roundRect">
+            <a:avLst>
+              <a:gd name="adj" fmla="val 16000"/>
+            </a:avLst>
+          </a:prstGeom>
+          <a:solidFill>
+            <a:srgbClr val="1E2761"/>
+          </a:solidFill>
+          <a:ln/>
+        </p:spPr>
+        <p:txBody>
+          <a:bodyPr/>
+          <a:lstStyle/>
+          <a:p>
+            <a:endParaRPr lang="ko-KR" altLang="en-US"/>
+          </a:p>
+        </p:txBody>
+      </p:sp>
+      <p:sp>
+        <p:nvSpPr>
+          <p:cNvPr id="7" name="Shape 5"/>
+          <p:cNvSpPr/>
+          <p:nvPr/>
+        </p:nvSpPr>
+        <p:spPr>
+          <a:xfrm>
+            <a:off x="548640" y="1417320"/>
+            <a:ext cx="11094415" cy="228600"/>
+          </a:xfrm>
+          <a:prstGeom prst="rect">
+            <a:avLst/>
+          </a:prstGeom>
+          <a:solidFill>
+            <a:srgbClr val="1E2761"/>
+          </a:solidFill>
+          <a:ln/>
+        </p:spPr>
+        <p:txBody>
+          <a:bodyPr/>
+          <a:lstStyle/>
+          <a:p>
+            <a:endParaRPr lang="ko-KR" altLang="en-US"/>
+          </a:p>
+        </p:txBody>
+      </p:sp>
+      <p:sp>
+        <p:nvSpPr>
+          <p:cNvPr id="8" name="Text 6"/>
+          <p:cNvSpPr/>
+          <p:nvPr/>
+        </p:nvSpPr>
+        <p:spPr>
+          <a:xfrm>
+            <a:off x="731520" y="1188720"/>
+            <a:ext cx="10728655" cy="457200"/>
+          </a:xfrm>
+          <a:prstGeom prst="rect">
+            <a:avLst/>
+          </a:prstGeom>
+          <a:noFill/>
+          <a:ln/>
+        </p:spPr>
+        <p:txBody>
+          <a:bodyPr wrap="square" rtlCol="0" anchor="ctr"/>
+          <a:lstStyle/>
+          <a:p>
+            <a:pPr marL="0" indent="0">
+              <a:buNone/>
+            </a:pPr>
+            <a:r>
+              <a:rPr lang="en-US" sz="1200" b="1" dirty="0">
+                <a:solidFill>
+                  <a:srgbClr val="CADCFC"/>
+                </a:solidFill>
+                <a:latin typeface="맑은 고딕" pitchFamily="34" charset="0"/>
+                <a:ea typeface="맑은 고딕" pitchFamily="34" charset="-122"/>
+                <a:cs typeface="맑은 고딕" pitchFamily="34" charset="-120"/>
+              </a:rPr>
+              <a:t>AK아이에스</a:t>
+            </a:r>
+            <a:endParaRPr lang="en-US" sz="950" dirty="0"/>
+          </a:p>
+        </p:txBody>
+      </p:sp>
+      <p:sp>
+        <p:nvSpPr>
+          <p:cNvPr id="9" name="Text 7"/>
+          <p:cNvSpPr/>
+          <p:nvPr/>
+        </p:nvSpPr>
+        <p:spPr>
+          <a:xfrm>
+            <a:off x="731520" y="1188720"/>
+            <a:ext cx="10728655" cy="457200"/>
+          </a:xfrm>
+          <a:prstGeom prst="rect">
+            <a:avLst/>
+          </a:prstGeom>
+          <a:noFill/>
+          <a:ln/>
+        </p:spPr>
+        <p:txBody>
+          <a:bodyPr wrap="square" rtlCol="0" anchor="ctr"/>
+          <a:lstStyle/>
+          <a:p>
+            <a:pPr marL="0" indent="0" algn="r">
+              <a:buNone/>
+            </a:pPr>
+            <a:r>
+              <a:rPr lang="en-US" sz="1200" b="1" dirty="0">
+                <a:solidFill>
+                  <a:srgbClr val="FFFFFF"/>
+                </a:solidFill>
+                <a:latin typeface="맑은 고딕" pitchFamily="34" charset="0"/>
+                <a:ea typeface="맑은 고딕" pitchFamily="34" charset="-122"/>
+                <a:cs typeface="맑은 고딕" pitchFamily="34" charset="-120"/>
+              </a:rPr>
+              <a:t>2021.07~2025.06</a:t>
+            </a:r>
+            <a:endParaRPr lang="en-US" sz="950" dirty="0"/>
+          </a:p>
+        </p:txBody>
+      </p:sp>
+      <p:sp>
+        <p:nvSpPr>
+          <p:cNvPr id="10" name="Text 8"/>
+          <p:cNvSpPr/>
+          <p:nvPr/>
+        </p:nvSpPr>
+        <p:spPr>
+          <a:xfrm>
+            <a:off x="777240" y="1783080"/>
+            <a:ext cx="10637215" cy="640080"/>
+          </a:xfrm>
+          <a:prstGeom prst="rect">
+            <a:avLst/>
+          </a:prstGeom>
+          <a:noFill/>
+          <a:ln/>
+        </p:spPr>
+        <p:txBody>
+          <a:bodyPr wrap="square" rtlCol="0" anchor="t"/>
+          <a:lstStyle/>
+          <a:p>
+            <a:pPr marL="0" indent="0">
+              <a:buNone/>
+            </a:pPr>
+            <a:r>
+              <a:rPr lang="en-US" sz="2000" b="1" dirty="0">
+                <a:solidFill>
+                  <a:srgbClr val="1E2761"/>
+                </a:solidFill>
+                <a:latin typeface="맑은 고딕" pitchFamily="34" charset="0"/>
+                <a:ea typeface="맑은 고딕" pitchFamily="34" charset="-122"/>
+                <a:cs typeface="맑은 고딕" pitchFamily="34" charset="-120"/>
+              </a:rPr>
+              <a:t>NetBackup → NetWorker 백업 체계 전환</a:t>
+            </a:r>
+            <a:endParaRPr lang="en-US" sz="1400" dirty="0"/>
+          </a:p>
+        </p:txBody>
+      </p:sp>
+      <p:sp>
+        <p:nvSpPr>
+          <p:cNvPr id="11" name="Text 9"/>
+          <p:cNvSpPr/>
+          <p:nvPr/>
+        </p:nvSpPr>
+        <p:spPr>
+          <a:xfrm>
+            <a:off x="777240" y="2514600"/>
+            <a:ext cx="10637215" cy="3429000"/>
+          </a:xfrm>
+          <a:prstGeom prst="rect">
+            <a:avLst/>
+          </a:prstGeom>
+          <a:noFill/>
+          <a:ln/>
+        </p:spPr>
+        <p:txBody>
+          <a:bodyPr wrap="square" rtlCol="0" anchor="t"/>
+          <a:lstStyle/>
+          <a:p>
+            <a:pPr marL="342900" indent="-342900">
+              <a:spcAft>
+                <a:spcPts val="900"/>
+              </a:spcAft>
+              <a:buSzPct val="100000"/>
+              <a:buChar char="▪"/>
+            </a:pPr>
+            <a:r>
+              <a:rPr lang="en-US" sz="1400" dirty="0">
+                <a:solidFill>
+                  <a:srgbClr val="1A1A2E"/>
+                </a:solidFill>
+                <a:latin typeface="맑은 고딕" pitchFamily="34" charset="0"/>
+                <a:ea typeface="맑은 고딕" pitchFamily="34" charset="-122"/>
+                <a:cs typeface="맑은 고딕" pitchFamily="34" charset="-120"/>
+              </a:rPr>
+              <a:t>EKS 전환으로 드러난 백업 체계 공백 확인, 온프렘 통합로그 서버 구축 및 ELK 설정</a:t>
+            </a:r>
+            <a:endParaRPr lang="en-US" sz="1000" dirty="0"/>
+          </a:p>
+          <a:p>
+            <a:pPr marL="342900" indent="-342900">
+              <a:spcAft>
+                <a:spcPts val="900"/>
+              </a:spcAft>
+              <a:buSzPct val="100000"/>
+              <a:buChar char="▪"/>
+            </a:pPr>
+            <a:r>
+              <a:rPr lang="en-US" sz="1400" dirty="0">
+                <a:solidFill>
+                  <a:srgbClr val="1A1A2E"/>
+                </a:solidFill>
+                <a:latin typeface="맑은 고딕" pitchFamily="34" charset="0"/>
+                <a:ea typeface="맑은 고딕" pitchFamily="34" charset="-122"/>
+                <a:cs typeface="맑은 고딕" pitchFamily="34" charset="-120"/>
+              </a:rPr>
+              <a:t>NetBackup → NetWorker 전환, 감사/컴플라이언스 대응 위해 시스템 중요도별 백업 보관기간·주기 정책 재정립</a:t>
+            </a:r>
+            <a:endParaRPr lang="en-US" sz="1000" dirty="0"/>
+          </a:p>
+          <a:p>
+            <a:pPr marL="342900" indent="-342900">
+              <a:spcAft>
+                <a:spcPts val="900"/>
+              </a:spcAft>
+              <a:buSzPct val="100000"/>
+              <a:buChar char="▪"/>
+            </a:pPr>
+            <a:r>
+              <a:rPr lang="en-US" sz="1400" dirty="0">
+                <a:solidFill>
+                  <a:srgbClr val="1A1A2E"/>
+                </a:solidFill>
+                <a:latin typeface="맑은 고딕" pitchFamily="34" charset="0"/>
+                <a:ea typeface="맑은 고딕" pitchFamily="34" charset="-122"/>
+                <a:cs typeface="맑은 고딕" pitchFamily="34" charset="-120"/>
+              </a:rPr>
+              <a:t>4년간(2021.07~2025.06) 약 500TB, 약 500건 규모 백업 지속 운영</a:t>
+            </a:r>
+            <a:endParaRPr lang="en-US" sz="1000" dirty="0"/>
+          </a:p>
+        </p:txBody>
+      </p:sp>
+      <p:sp>
+        <p:nvSpPr>
+          <p:cNvPr id="12" name="Text 10"/>
+          <p:cNvSpPr/>
+          <p:nvPr/>
+        </p:nvSpPr>
+        <p:spPr>
+          <a:xfrm>
+            <a:off x="777240" y="5852160"/>
+            <a:ext cx="10637215" cy="411480"/>
+          </a:xfrm>
+          <a:prstGeom prst="rect">
+            <a:avLst/>
+          </a:prstGeom>
+          <a:noFill/>
+          <a:ln/>
+        </p:spPr>
+        <p:txBody>
+          <a:bodyPr wrap="square" rtlCol="0" anchor="ctr"/>
+          <a:lstStyle/>
+          <a:p>
+            <a:pPr marL="0" indent="0">
+              <a:buNone/>
+            </a:pPr>
+            <a:r>
+              <a:rPr lang="en-US" sz="1200" b="1" dirty="0">
+                <a:solidFill>
+                  <a:srgbClr val="1E2761"/>
+                </a:solidFill>
+                <a:latin typeface="맑은 고딕" pitchFamily="34" charset="0"/>
+                <a:ea typeface="맑은 고딕" pitchFamily="34" charset="-122"/>
+                <a:cs typeface="맑은 고딕" pitchFamily="34" charset="-120"/>
+              </a:rPr>
+              <a:t>결과 — 백업·복구 기반 장애 시간 최소화 기여, 감사 대응 백업 정책 표준화</a:t>
+            </a:r>
+            <a:endParaRPr lang="en-US" sz="950" dirty="0"/>
+          </a:p>
+        </p:txBody>
+      </p:sp>
+    </p:spTree>
+  </p:cSld>
+  <p:clrMapOvr>
+    <a:masterClrMapping/>
+  </p:clrMapOvr>
+</p:sld>
+</file>
+
+<file path=ppt/slides/slide9.xml><?xml version="1.0" encoding="utf-8"?>
 <p:sld xmlns:a="http://schemas.openxmlformats.org/drawingml/2006/main" xmlns:r="http://schemas.openxmlformats.org/officeDocument/2006/relationships" xmlns:p="http://schemas.openxmlformats.org/presentationml/2006/main">
   <p:cSld name="Slide 8">
     <p:bg>
@@ -9346,156 +9973,6 @@
               <a:t>▶ 전 계정 매일 스캔, 개발자 포탈에서 상시 확인</a:t>
             </a:r>
             <a:endParaRPr lang="en-US" sz="1000" dirty="0"/>
-          </a:p>
-        </p:txBody>
-      </p:sp>
-    </p:spTree>
-  </p:cSld>
-  <p:clrMapOvr>
-    <a:masterClrMapping/>
-  </p:clrMapOvr>
-</p:sld>
-</file>
-
-<file path=ppt/slides/slide9.xml><?xml version="1.0" encoding="utf-8"?>
-<p:sld xmlns:a="http://schemas.openxmlformats.org/drawingml/2006/main" xmlns:r="http://schemas.openxmlformats.org/officeDocument/2006/relationships" xmlns:p="http://schemas.openxmlformats.org/presentationml/2006/main">
-  <p:cSld name="Slide 9">
-    <p:bg>
-      <p:bgPr>
-        <a:solidFill>
-          <a:srgbClr val="1E2761"/>
-        </a:solidFill>
-        <a:effectLst/>
-      </p:bgPr>
-    </p:bg>
-    <p:spTree>
-      <p:nvGrpSpPr>
-        <p:cNvPr id="1" name=""/>
-        <p:cNvGrpSpPr/>
-        <p:nvPr/>
-      </p:nvGrpSpPr>
-      <p:grpSpPr>
-        <a:xfrm>
-          <a:off x="0" y="0"/>
-          <a:ext cx="0" cy="0"/>
-          <a:chOff x="0" y="0"/>
-          <a:chExt cx="0" cy="0"/>
-        </a:xfrm>
-      </p:grpSpPr>
-      <p:sp>
-        <p:nvSpPr>
-          <p:cNvPr id="2" name="Text 0"/>
-          <p:cNvSpPr/>
-          <p:nvPr/>
-        </p:nvSpPr>
-        <p:spPr>
-          <a:xfrm>
-            <a:off x="548640" y="2286000"/>
-            <a:ext cx="7315200" cy="365760"/>
-          </a:xfrm>
-          <a:prstGeom prst="rect">
-            <a:avLst/>
-          </a:prstGeom>
-          <a:noFill/>
-          <a:ln/>
-        </p:spPr>
-        <p:txBody>
-          <a:bodyPr wrap="square" rtlCol="0" anchor="ctr"/>
-          <a:lstStyle/>
-          <a:p>
-            <a:pPr marL="0" indent="0">
-              <a:buNone/>
-            </a:pPr>
-            <a:r>
-              <a:rPr lang="en-US" sz="1300" b="1" kern="0" spc="200" dirty="0">
-                <a:solidFill>
-                  <a:srgbClr val="CADCFC"/>
-                </a:solidFill>
-                <a:latin typeface="맑은 고딕" pitchFamily="34" charset="0"/>
-                <a:ea typeface="맑은 고딕" pitchFamily="34" charset="-122"/>
-                <a:cs typeface="맑은 고딕" pitchFamily="34" charset="-120"/>
-              </a:rPr>
-              <a:t>THANK YOU</a:t>
-            </a:r>
-            <a:endParaRPr lang="en-US" sz="1300" dirty="0"/>
-          </a:p>
-        </p:txBody>
-      </p:sp>
-      <p:sp>
-        <p:nvSpPr>
-          <p:cNvPr id="3" name="Text 1"/>
-          <p:cNvSpPr/>
-          <p:nvPr/>
-        </p:nvSpPr>
-        <p:spPr>
-          <a:xfrm>
-            <a:off x="548640" y="2697480"/>
-            <a:ext cx="9144000" cy="1188720"/>
-          </a:xfrm>
-          <a:prstGeom prst="rect">
-            <a:avLst/>
-          </a:prstGeom>
-          <a:noFill/>
-          <a:ln/>
-        </p:spPr>
-        <p:txBody>
-          <a:bodyPr wrap="square" rtlCol="0" anchor="ctr"/>
-          <a:lstStyle/>
-          <a:p>
-            <a:pPr marL="0" indent="0">
-              <a:buNone/>
-            </a:pPr>
-            <a:r>
-              <a:rPr lang="en-US" sz="4000" b="1" dirty="0">
-                <a:solidFill>
-                  <a:srgbClr val="FFFFFF"/>
-                </a:solidFill>
-                <a:latin typeface="맑은 고딕" pitchFamily="34" charset="0"/>
-                <a:ea typeface="맑은 고딕" pitchFamily="34" charset="-122"/>
-                <a:cs typeface="맑은 고딕" pitchFamily="34" charset="-120"/>
-              </a:rPr>
-              <a:t>감사합니다</a:t>
-            </a:r>
-            <a:endParaRPr lang="en-US" sz="4000" dirty="0"/>
-          </a:p>
-        </p:txBody>
-      </p:sp>
-      <p:sp>
-        <p:nvSpPr>
-          <p:cNvPr id="4" name="Text 2"/>
-          <p:cNvSpPr/>
-          <p:nvPr/>
-        </p:nvSpPr>
-        <p:spPr>
-          <a:xfrm>
-            <a:off x="548640" y="3749040"/>
-            <a:ext cx="8229600" cy="457200"/>
-          </a:xfrm>
-          <a:prstGeom prst="rect">
-            <a:avLst/>
-          </a:prstGeom>
-          <a:noFill/>
-          <a:ln/>
-        </p:spPr>
-        <p:txBody>
-          <a:bodyPr wrap="square" rtlCol="0" anchor="ctr"/>
-          <a:lstStyle/>
-          <a:p>
-            <a:pPr marL="0" indent="0">
-              <a:buNone/>
-            </a:pPr>
-            <a:r>
-              <a:rPr lang="en-US" sz="1800" dirty="0">
-                <a:solidFill>
-                  <a:srgbClr val="CADCFC"/>
-                </a:solidFill>
-                <a:latin typeface="맑은 고딕" pitchFamily="34" charset="0"/>
-                <a:ea typeface="맑은 고딕" pitchFamily="34" charset="-122"/>
-                <a:cs typeface="맑은 고딕" pitchFamily="34" charset="-120"/>
-              </a:rPr>
-              <a:t>정상윤</a:t>
-            </a:r>
-            <a:endParaRPr lang="en-US" sz="1800" dirty="0"/>
           </a:p>
         </p:txBody>
       </p:sp>

</xml_diff>

<commit_message>
vault backup: 2026-09-08 15:20:11
</commit_message>
<xml_diff>
--- a/포트폴리오_정상윤_2026_v2.pptx
+++ b/포트폴리오_정상윤_2026_v2.pptx
@@ -5,7 +5,7 @@
     <p:sldMasterId id="2147483648" r:id="rId1"/>
   </p:sldMasterIdLst>
   <p:notesMasterIdLst>
-    <p:notesMasterId r:id="rId11"/>
+    <p:notesMasterId r:id="rId12"/>
   </p:notesMasterIdLst>
   <p:sldIdLst>
     <p:sldId id="256" r:id="rId2"/>
@@ -15,9 +15,9 @@
     <p:sldId id="260" r:id="rId6"/>
     <p:sldId id="261" r:id="rId7"/>
     <p:sldId id="262" r:id="rId8"/>
-    <p:sldId id="266" r:id="rId16"/>
-    <p:sldId id="263" r:id="rId9"/>
-    <p:sldId id="264" r:id="rId10"/>
+    <p:sldId id="266" r:id="rId9"/>
+    <p:sldId id="263" r:id="rId10"/>
+    <p:sldId id="264" r:id="rId11"/>
   </p:sldIdLst>
   <p:sldSz cx="12192000" cy="6858000"/>
   <p:notesSz cx="6858000" cy="12192000"/>
@@ -899,7 +899,7 @@
           <a:p>
             <a:fld id="{F7021451-1387-4CA6-816F-3879F97B5CBC}" type="slidenum">
               <a:rPr lang="en-US"/>
-              <a:t>8</a:t>
+              <a:t>9</a:t>
             </a:fld>
             <a:endParaRPr lang="en-US"/>
           </a:p>
@@ -983,7 +983,7 @@
           <a:p>
             <a:fld id="{F7021451-1387-4CA6-816F-3879F97B5CBC}" type="slidenum">
               <a:rPr lang="en-US"/>
-              <a:t>9</a:t>
+              <a:t>10</a:t>
             </a:fld>
             <a:endParaRPr lang="en-US"/>
           </a:p>
@@ -6599,7 +6599,7 @@
                 <a:ea typeface="맑은 고딕" pitchFamily="34" charset="-122"/>
                 <a:cs typeface="맑은 고딕" pitchFamily="34" charset="-120"/>
               </a:rPr>
-              <a:t>TelePIX</a:t>
+              <a:t>AK아이에스</a:t>
             </a:r>
             <a:endParaRPr lang="en-US" sz="950" dirty="0"/>
           </a:p>
@@ -6638,7 +6638,7 @@
                 <a:ea typeface="맑은 고딕" pitchFamily="34" charset="-122"/>
                 <a:cs typeface="맑은 고딕" pitchFamily="34" charset="-120"/>
               </a:rPr>
-              <a:t>2026.06~07</a:t>
+              <a:t>2021.07~2025.06</a:t>
             </a:r>
             <a:endParaRPr lang="en-US" sz="950" dirty="0"/>
           </a:p>
@@ -6677,7 +6677,7 @@
                 <a:ea typeface="맑은 고딕" pitchFamily="34" charset="-122"/>
                 <a:cs typeface="맑은 고딕" pitchFamily="34" charset="-120"/>
               </a:rPr>
-              <a:t>GPU 딥러닝 서빙 마이그레이션</a:t>
+              <a:t>NetBackup → NetWorker 백업 체계 전환</a:t>
             </a:r>
             <a:endParaRPr lang="en-US" sz="1400" dirty="0"/>
           </a:p>
@@ -6720,7 +6720,7 @@
                 <a:ea typeface="맑은 고딕" pitchFamily="34" charset="-122"/>
                 <a:cs typeface="맑은 고딕" pitchFamily="34" charset="-120"/>
               </a:rPr>
-              <a:t>이중화·모니터링·배포자동화 없던 온프렘 GPU 서버를 ECS로 이관</a:t>
+              <a:t>EKS 전환으로 드러난 백업 체계 공백 확인, 온프렘 통합로그 서버 구축 및 ELK 설정</a:t>
             </a:r>
             <a:endParaRPr lang="en-US" sz="1000" dirty="0"/>
           </a:p>
@@ -6741,7 +6741,7 @@
                 <a:ea typeface="맑은 고딕" pitchFamily="34" charset="-122"/>
                 <a:cs typeface="맑은 고딕" pitchFamily="34" charset="-120"/>
               </a:rPr>
-              <a:t>단일 GPU 인스턴스에 서비스 3개를 VRAM 예산 맞춰 스케줄링 설계</a:t>
+              <a:t>NetBackup → NetWorker 전환, 감사/컴플라이언스 대응 위해 시스템 중요도별 백업 보관기간·주기 정책 재정립</a:t>
             </a:r>
             <a:endParaRPr lang="en-US" sz="1000" dirty="0"/>
           </a:p>
@@ -6762,7 +6762,7 @@
                 <a:ea typeface="맑은 고딕" pitchFamily="34" charset="-122"/>
                 <a:cs typeface="맑은 고딕" pitchFamily="34" charset="-120"/>
               </a:rPr>
-              <a:t>콘솔로 급조한 ALB/타겟그룹을 Terraform으로 편입, 관리 일원화</a:t>
+              <a:t>4년간(2021.07~2025.06) 약 500TB, 약 500건 규모 백업 지속 운영</a:t>
             </a:r>
             <a:endParaRPr lang="en-US" sz="1000" dirty="0"/>
           </a:p>
@@ -6801,7 +6801,7 @@
                 <a:ea typeface="맑은 고딕" pitchFamily="34" charset="-122"/>
                 <a:cs typeface="맑은 고딕" pitchFamily="34" charset="-120"/>
               </a:rPr>
-              <a:t>결과 — ECS 3개 서비스 정상 운영, Terraform 단독 관리 전환</a:t>
+              <a:t>결과 — 백업·복구 기반 장애 시간 최소화 기여, 감사 대응 백업 정책 표준화</a:t>
             </a:r>
             <a:endParaRPr lang="en-US" sz="950" dirty="0"/>
           </a:p>
@@ -7015,7 +7015,7 @@
                 <a:ea typeface="맑은 고딕" pitchFamily="34" charset="-122"/>
                 <a:cs typeface="맑은 고딕" pitchFamily="34" charset="-120"/>
               </a:rPr>
-              <a:t>온프렘 보안 모니터링 스택 구축</a:t>
+              <a:t>GPU 딥러닝 서빙 마이그레이션</a:t>
             </a:r>
             <a:endParaRPr lang="en-US" sz="1400" dirty="0"/>
           </a:p>
@@ -7058,7 +7058,7 @@
                 <a:ea typeface="맑은 고딕" pitchFamily="34" charset="-122"/>
                 <a:cs typeface="맑은 고딕" pitchFamily="34" charset="-120"/>
               </a:rPr>
-              <a:t>네트워크(Suricata)→호스트(Wazuh)→인증(IAM Roles Anywhere)→리포트(Slack) 계층 설계</a:t>
+              <a:t>이중화·모니터링·배포자동화 없던 온프렘 GPU 서버를 ECS로 이관</a:t>
             </a:r>
             <a:endParaRPr lang="en-US" sz="1000" dirty="0"/>
           </a:p>
@@ -7079,7 +7079,7 @@
                 <a:ea typeface="맑은 고딕" pitchFamily="34" charset="-122"/>
                 <a:cs typeface="맑은 고딕" pitchFamily="34" charset="-120"/>
               </a:rPr>
-              <a:t>탐지 초기 노이즈(veth 오탐 등) 커스텀 룰로 제거 — High 2,725건→0건</a:t>
+              <a:t>단일 GPU 인스턴스에 서비스 3개를 VRAM 예산 맞춰 스케줄링 설계</a:t>
             </a:r>
             <a:endParaRPr lang="en-US" sz="1000" dirty="0"/>
           </a:p>
@@ -7100,7 +7100,7 @@
                 <a:ea typeface="맑은 고딕" pitchFamily="34" charset="-122"/>
                 <a:cs typeface="맑은 고딕" pitchFamily="34" charset="-120"/>
               </a:rPr>
-              <a:t>Wazuh/GuardDuty/CloudTrail 통합 Slack 데일리 리포트 체계 구축</a:t>
+              <a:t>콘솔로 급조한 ALB/타겟그룹을 Terraform으로 편입, 관리 일원화</a:t>
             </a:r>
             <a:endParaRPr lang="en-US" sz="1000" dirty="0"/>
           </a:p>
@@ -7139,7 +7139,7 @@
                 <a:ea typeface="맑은 고딕" pitchFamily="34" charset="-122"/>
                 <a:cs typeface="맑은 고딕" pitchFamily="34" charset="-120"/>
               </a:rPr>
-              <a:t>결과 — 3대 서버 상시 탐지·매일 아침 통합 보안 리포트 운영</a:t>
+              <a:t>결과 — ECS 3개 서비스 정상 운영, Terraform 단독 관리 전환</a:t>
             </a:r>
             <a:endParaRPr lang="en-US" sz="950" dirty="0"/>
           </a:p>
@@ -7452,7 +7452,7 @@
                 <a:ea typeface="맑은 고딕" pitchFamily="34" charset="-122"/>
                 <a:cs typeface="맑은 고딕" pitchFamily="34" charset="-120"/>
               </a:rPr>
-              <a:t>2026.08</a:t>
+              <a:t>2026.06~07</a:t>
             </a:r>
             <a:endParaRPr lang="en-US" sz="950" dirty="0"/>
           </a:p>
@@ -7491,7 +7491,7 @@
                 <a:ea typeface="맑은 고딕" pitchFamily="34" charset="-122"/>
                 <a:cs typeface="맑은 고딕" pitchFamily="34" charset="-120"/>
               </a:rPr>
-              <a:t>IAM 이상탐지 대응 &amp; CSPM 도입</a:t>
+              <a:t>온프렘 보안 모니터링 스택 구축</a:t>
             </a:r>
             <a:endParaRPr lang="en-US" sz="1400" dirty="0"/>
           </a:p>
@@ -7534,7 +7534,7 @@
                 <a:ea typeface="맑은 고딕" pitchFamily="34" charset="-122"/>
                 <a:cs typeface="맑은 고딕" pitchFamily="34" charset="-120"/>
               </a:rPr>
-              <a:t>GuardDuty 기반 이상 탐지 시나리오 대응, IAM 액세스키 이상 사용 확인 및 조치</a:t>
+              <a:t>네트워크(Suricata)→호스트(Wazuh)→인증(IAM Roles Anywhere)→리포트(Slack) 계층 설계</a:t>
             </a:r>
             <a:endParaRPr lang="en-US" sz="1000" dirty="0"/>
           </a:p>
@@ -7555,7 +7555,51 @@
                 <a:ea typeface="맑은 고딕" pitchFamily="34" charset="-122"/>
                 <a:cs typeface="맑은 고딕" pitchFamily="34" charset="-120"/>
               </a:rPr>
-              <a:t>대응 중 'AWS 설정 상시 감사 수단 부재'라는 근본 공백 확인</a:t>
+              <a:t>탐지 초기 </a:t>
+            </a:r>
+            <a:r>
+              <a:rPr lang="en-US" sz="1000" dirty="0" err="1">
+                <a:solidFill>
+                  <a:srgbClr val="1A1A2E"/>
+                </a:solidFill>
+                <a:latin typeface="맑은 고딕" pitchFamily="34" charset="0"/>
+                <a:ea typeface="맑은 고딕" pitchFamily="34" charset="-122"/>
+                <a:cs typeface="맑은 고딕" pitchFamily="34" charset="-120"/>
+              </a:rPr>
+              <a:t>노이즈</a:t>
+            </a:r>
+            <a:r>
+              <a:rPr lang="en-US" sz="1000" dirty="0">
+                <a:solidFill>
+                  <a:srgbClr val="1A1A2E"/>
+                </a:solidFill>
+                <a:latin typeface="맑은 고딕" pitchFamily="34" charset="0"/>
+                <a:ea typeface="맑은 고딕" pitchFamily="34" charset="-122"/>
+                <a:cs typeface="맑은 고딕" pitchFamily="34" charset="-120"/>
+              </a:rPr>
+              <a:t>(</a:t>
+            </a:r>
+            <a:r>
+              <a:rPr lang="en-US" sz="1000" dirty="0" err="1">
+                <a:solidFill>
+                  <a:srgbClr val="1A1A2E"/>
+                </a:solidFill>
+                <a:latin typeface="맑은 고딕" pitchFamily="34" charset="0"/>
+                <a:ea typeface="맑은 고딕" pitchFamily="34" charset="-122"/>
+                <a:cs typeface="맑은 고딕" pitchFamily="34" charset="-120"/>
+              </a:rPr>
+              <a:t>오탐</a:t>
+            </a:r>
+            <a:r>
+              <a:rPr lang="en-US" sz="1000" dirty="0">
+                <a:solidFill>
+                  <a:srgbClr val="1A1A2E"/>
+                </a:solidFill>
+                <a:latin typeface="맑은 고딕" pitchFamily="34" charset="0"/>
+                <a:ea typeface="맑은 고딕" pitchFamily="34" charset="-122"/>
+                <a:cs typeface="맑은 고딕" pitchFamily="34" charset="-120"/>
+              </a:rPr>
+              <a:t> 등) 커스텀 룰로 제거 — High 2,725건→0건</a:t>
             </a:r>
             <a:endParaRPr lang="en-US" sz="1000" dirty="0"/>
           </a:p>
@@ -7576,7 +7620,7 @@
                 <a:ea typeface="맑은 고딕" pitchFamily="34" charset="-122"/>
                 <a:cs typeface="맑은 고딕" pitchFamily="34" charset="-120"/>
               </a:rPr>
-              <a:t>CSPM(Prowler) Self-Hosted 구축, 스캔 결과를 개발자 포탈에 연동</a:t>
+              <a:t>Wazuh/GuardDuty/CloudTrail 통합 Slack 데일리 리포트 체계 구축</a:t>
             </a:r>
             <a:endParaRPr lang="en-US" sz="1000" dirty="0"/>
           </a:p>
@@ -7615,7 +7659,7 @@
                 <a:ea typeface="맑은 고딕" pitchFamily="34" charset="-122"/>
                 <a:cs typeface="맑은 고딕" pitchFamily="34" charset="-120"/>
               </a:rPr>
-              <a:t>결과 — 사후 대응(로깅)에서 사전 예방(상시 감사)까지 체계 확장</a:t>
+              <a:t>결과 — 3대 서버 상시 탐지·매일 아침 통합 보안 리포트 운영</a:t>
             </a:r>
             <a:endParaRPr lang="en-US" sz="950" dirty="0"/>
           </a:p>
@@ -7790,7 +7834,7 @@
                 <a:ea typeface="맑은 고딕" pitchFamily="34" charset="-122"/>
                 <a:cs typeface="맑은 고딕" pitchFamily="34" charset="-120"/>
               </a:rPr>
-              <a:t>2026</a:t>
+              <a:t>2026.08</a:t>
             </a:r>
             <a:endParaRPr lang="en-US" sz="950" dirty="0"/>
           </a:p>
@@ -7829,7 +7873,7 @@
                 <a:ea typeface="맑은 고딕" pitchFamily="34" charset="-122"/>
                 <a:cs typeface="맑은 고딕" pitchFamily="34" charset="-120"/>
               </a:rPr>
-              <a:t>사내 개발자 포탈 구축</a:t>
+              <a:t>IAM 이상탐지 대응 &amp; CSPM 도입</a:t>
             </a:r>
             <a:endParaRPr lang="en-US" sz="1400" dirty="0"/>
           </a:p>
@@ -7872,7 +7916,7 @@
                 <a:ea typeface="맑은 고딕" pitchFamily="34" charset="-122"/>
                 <a:cs typeface="맑은 고딕" pitchFamily="34" charset="-120"/>
               </a:rPr>
-              <a:t>Keycloak SSO 연동, 신규 서버 편입 시 계정/키 세팅 자동화</a:t>
+              <a:t>GuardDuty 기반 이상 탐지 시나리오 대응, IAM 액세스키 이상 사용 확인 및 조치</a:t>
             </a:r>
             <a:endParaRPr lang="en-US" sz="1000" dirty="0"/>
           </a:p>
@@ -7893,7 +7937,7 @@
                 <a:ea typeface="맑은 고딕" pitchFamily="34" charset="-122"/>
                 <a:cs typeface="맑은 고딕" pitchFamily="34" charset="-120"/>
               </a:rPr>
-              <a:t>ECS 서비스 카탈로그·실시간 상태 대시보드 구축</a:t>
+              <a:t>대응 중 'AWS 설정 상시 감사 수단 부재'라는 근본 공백 확인</a:t>
             </a:r>
             <a:endParaRPr lang="en-US" sz="1000" dirty="0"/>
           </a:p>
@@ -7914,7 +7958,7 @@
                 <a:ea typeface="맑은 고딕" pitchFamily="34" charset="-122"/>
                 <a:cs typeface="맑은 고딕" pitchFamily="34" charset="-120"/>
               </a:rPr>
-              <a:t>모니터링 알림→슬랙 등록 수동 흐름을 장애 관리 자동화로 전환</a:t>
+              <a:t>CSPM(Prowler) Self-Hosted 구축, 스캔 결과를 개발자 포탈에 연동</a:t>
             </a:r>
             <a:endParaRPr lang="en-US" sz="1000" dirty="0"/>
           </a:p>
@@ -7953,7 +7997,7 @@
                 <a:ea typeface="맑은 고딕" pitchFamily="34" charset="-122"/>
                 <a:cs typeface="맑은 고딕" pitchFamily="34" charset="-120"/>
               </a:rPr>
-              <a:t>결과 — 접근제어/장애관리 전 과정 셀프서비스화</a:t>
+              <a:t>결과 — 사후 대응(로깅)에서 사전 예방(상시 감사)까지 체계 확장</a:t>
             </a:r>
             <a:endParaRPr lang="en-US" sz="950" dirty="0"/>
           </a:p>
@@ -8128,7 +8172,7 @@
                 <a:ea typeface="맑은 고딕" pitchFamily="34" charset="-122"/>
                 <a:cs typeface="맑은 고딕" pitchFamily="34" charset="-120"/>
               </a:rPr>
-              <a:t>2026.08</a:t>
+              <a:t>2026</a:t>
             </a:r>
             <a:endParaRPr lang="en-US" sz="950" dirty="0"/>
           </a:p>
@@ -8167,7 +8211,7 @@
                 <a:ea typeface="맑은 고딕" pitchFamily="34" charset="-122"/>
                 <a:cs typeface="맑은 고딕" pitchFamily="34" charset="-120"/>
               </a:rPr>
-              <a:t>CI/CD 파이프라인 고도화</a:t>
+              <a:t>사내 개발자 포탈 구축</a:t>
             </a:r>
             <a:endParaRPr lang="en-US" sz="1400" dirty="0"/>
           </a:p>
@@ -8210,7 +8254,7 @@
                 <a:ea typeface="맑은 고딕" pitchFamily="34" charset="-122"/>
                 <a:cs typeface="맑은 고딕" pitchFamily="34" charset="-120"/>
               </a:rPr>
-              <a:t>Bitbucket Pipelines 기반 Terraform PR 파이프라인 — 변경 디렉토리·모듈 의존 관계 자동 탐지 후 plan 실행, OIDC로 AWS 역할 assume</a:t>
+              <a:t>Keycloak SSO 연동, 신규 서버 편입 시 계정/키 세팅 자동화</a:t>
             </a:r>
             <a:endParaRPr lang="en-US" sz="1000" dirty="0"/>
           </a:p>
@@ -8231,7 +8275,7 @@
                 <a:ea typeface="맑은 고딕" pitchFamily="34" charset="-122"/>
                 <a:cs typeface="맑은 고딕" pitchFamily="34" charset="-120"/>
               </a:rPr>
-              <a:t>plan 노이즈 필터링으로 리뷰어가 실제 변경 리소스만 확인 가능하도록 개선</a:t>
+              <a:t>ECS 서비스 카탈로그·실시간 상태 대시보드 구축</a:t>
             </a:r>
             <a:endParaRPr lang="en-US" sz="1000" dirty="0"/>
           </a:p>
@@ -8252,28 +8296,7 @@
                 <a:ea typeface="맑은 고딕" pitchFamily="34" charset="-122"/>
                 <a:cs typeface="맑은 고딕" pitchFamily="34" charset="-120"/>
               </a:rPr>
-              <a:t>.env 관리 자동화 — git 대신 S3로 분리, 파이프라인 Role에 GetObject만 최소 권한 부여해 plan 실패 문제 해결</a:t>
-            </a:r>
-            <a:endParaRPr lang="en-US" sz="1000" dirty="0"/>
-          </a:p>
-          <a:p>
-            <a:pPr marL="342900" indent="-342900">
-              <a:spcAft>
-                <a:spcPts val="900"/>
-              </a:spcAft>
-              <a:buSzPct val="100000"/>
-              <a:buChar char="▪"/>
-            </a:pPr>
-            <a:r>
-              <a:rPr lang="en-US" sz="1000" dirty="0">
-                <a:solidFill>
-                  <a:srgbClr val="1A1A2E"/>
-                </a:solidFill>
-                <a:latin typeface="맑은 고딕" pitchFamily="34" charset="0"/>
-                <a:ea typeface="맑은 고딕" pitchFamily="34" charset="-122"/>
-                <a:cs typeface="맑은 고딕" pitchFamily="34" charset="-120"/>
-              </a:rPr>
-              <a:t>배포 승인 게이트 — 포탈 승인을 Bitbucket API로 서버가 재검증하는 상태머신 설계, 웹훅 차단 환경은 폴링으로 우회</a:t>
+              <a:t>모니터링 알림→슬랙 등록 수동 흐름을 장애 관리 자동화로 전환</a:t>
             </a:r>
             <a:endParaRPr lang="en-US" sz="1000" dirty="0"/>
           </a:p>
@@ -8312,7 +8335,7 @@
                 <a:ea typeface="맑은 고딕" pitchFamily="34" charset="-122"/>
                 <a:cs typeface="맑은 고딕" pitchFamily="34" charset="-120"/>
               </a:rPr>
-              <a:t>결과 — 무리뷰 배포 구조 차단 및 PR 파이프라인 안정화</a:t>
+              <a:t>결과 — 접근제어/장애관리 전 과정 셀프서비스화</a:t>
             </a:r>
             <a:endParaRPr lang="en-US" sz="950" dirty="0"/>
           </a:p>
@@ -8465,7 +8488,7 @@
         <p:spPr>
           <a:xfrm>
             <a:off x="548640" y="1188720"/>
-            <a:ext cx="11094415" cy="5166360"/>
+            <a:ext cx="3484778" cy="5166360"/>
           </a:xfrm>
           <a:prstGeom prst="roundRect">
             <a:avLst>
@@ -8506,7 +8529,7 @@
         <p:spPr>
           <a:xfrm>
             <a:off x="548640" y="1188720"/>
-            <a:ext cx="11094415" cy="457200"/>
+            <a:ext cx="3484778" cy="457200"/>
           </a:xfrm>
           <a:prstGeom prst="roundRect">
             <a:avLst>
@@ -8535,7 +8558,7 @@
         <p:spPr>
           <a:xfrm>
             <a:off x="548640" y="1417320"/>
-            <a:ext cx="11094415" cy="228600"/>
+            <a:ext cx="3484778" cy="228600"/>
           </a:xfrm>
           <a:prstGeom prst="rect">
             <a:avLst/>
@@ -8562,7 +8585,7 @@
         <p:spPr>
           <a:xfrm>
             <a:off x="731520" y="1188720"/>
-            <a:ext cx="10728655" cy="457200"/>
+            <a:ext cx="3119018" cy="457200"/>
           </a:xfrm>
           <a:prstGeom prst="rect">
             <a:avLst/>
@@ -8578,7 +8601,7 @@
               <a:buNone/>
             </a:pPr>
             <a:r>
-              <a:rPr lang="en-US" sz="1200" b="1" dirty="0">
+              <a:rPr lang="en-US" sz="950" b="1" dirty="0">
                 <a:solidFill>
                   <a:srgbClr val="CADCFC"/>
                 </a:solidFill>
@@ -8586,7 +8609,7 @@
                 <a:ea typeface="맑은 고딕" pitchFamily="34" charset="-122"/>
                 <a:cs typeface="맑은 고딕" pitchFamily="34" charset="-120"/>
               </a:rPr>
-              <a:t>AK아이에스</a:t>
+              <a:t>TelePIX</a:t>
             </a:r>
             <a:endParaRPr lang="en-US" sz="950" dirty="0"/>
           </a:p>
@@ -8601,7 +8624,7 @@
         <p:spPr>
           <a:xfrm>
             <a:off x="731520" y="1188720"/>
-            <a:ext cx="10728655" cy="457200"/>
+            <a:ext cx="3119018" cy="457200"/>
           </a:xfrm>
           <a:prstGeom prst="rect">
             <a:avLst/>
@@ -8617,7 +8640,7 @@
               <a:buNone/>
             </a:pPr>
             <a:r>
-              <a:rPr lang="en-US" sz="1200" b="1" dirty="0">
+              <a:rPr lang="en-US" sz="950" b="1" dirty="0">
                 <a:solidFill>
                   <a:srgbClr val="FFFFFF"/>
                 </a:solidFill>
@@ -8625,7 +8648,7 @@
                 <a:ea typeface="맑은 고딕" pitchFamily="34" charset="-122"/>
                 <a:cs typeface="맑은 고딕" pitchFamily="34" charset="-120"/>
               </a:rPr>
-              <a:t>2021.07~2025.06</a:t>
+              <a:t>2026.08</a:t>
             </a:r>
             <a:endParaRPr lang="en-US" sz="950" dirty="0"/>
           </a:p>
@@ -8640,7 +8663,7 @@
         <p:spPr>
           <a:xfrm>
             <a:off x="777240" y="1783080"/>
-            <a:ext cx="10637215" cy="640080"/>
+            <a:ext cx="3027578" cy="640080"/>
           </a:xfrm>
           <a:prstGeom prst="rect">
             <a:avLst/>
@@ -8656,7 +8679,7 @@
               <a:buNone/>
             </a:pPr>
             <a:r>
-              <a:rPr lang="en-US" sz="2000" b="1" dirty="0">
+              <a:rPr lang="en-US" sz="1400" b="1" dirty="0">
                 <a:solidFill>
                   <a:srgbClr val="1E2761"/>
                 </a:solidFill>
@@ -8664,7 +8687,7 @@
                 <a:ea typeface="맑은 고딕" pitchFamily="34" charset="-122"/>
                 <a:cs typeface="맑은 고딕" pitchFamily="34" charset="-120"/>
               </a:rPr>
-              <a:t>NetBackup → NetWorker 백업 체계 전환</a:t>
+              <a:t>CI/CD 파이프라인 고도화</a:t>
             </a:r>
             <a:endParaRPr lang="en-US" sz="1400" dirty="0"/>
           </a:p>
@@ -8679,7 +8702,7 @@
         <p:spPr>
           <a:xfrm>
             <a:off x="777240" y="2514600"/>
-            <a:ext cx="10637215" cy="3429000"/>
+            <a:ext cx="3027578" cy="3429000"/>
           </a:xfrm>
           <a:prstGeom prst="rect">
             <a:avLst/>
@@ -8699,7 +8722,7 @@
               <a:buChar char="▪"/>
             </a:pPr>
             <a:r>
-              <a:rPr lang="en-US" sz="1400" dirty="0">
+              <a:rPr lang="en-US" sz="1000" dirty="0">
                 <a:solidFill>
                   <a:srgbClr val="1A1A2E"/>
                 </a:solidFill>
@@ -8707,7 +8730,7 @@
                 <a:ea typeface="맑은 고딕" pitchFamily="34" charset="-122"/>
                 <a:cs typeface="맑은 고딕" pitchFamily="34" charset="-120"/>
               </a:rPr>
-              <a:t>EKS 전환으로 드러난 백업 체계 공백 확인, 온프렘 통합로그 서버 구축 및 ELK 설정</a:t>
+              <a:t>Bitbucket Pipelines 기반 Terraform PR 파이프라인 — 변경 디렉토리·모듈 의존 관계 자동 탐지 후 plan 실행, OIDC로 AWS 역할 assume</a:t>
             </a:r>
             <a:endParaRPr lang="en-US" sz="1000" dirty="0"/>
           </a:p>
@@ -8720,7 +8743,7 @@
               <a:buChar char="▪"/>
             </a:pPr>
             <a:r>
-              <a:rPr lang="en-US" sz="1400" dirty="0">
+              <a:rPr lang="en-US" sz="1000" dirty="0">
                 <a:solidFill>
                   <a:srgbClr val="1A1A2E"/>
                 </a:solidFill>
@@ -8728,7 +8751,7 @@
                 <a:ea typeface="맑은 고딕" pitchFamily="34" charset="-122"/>
                 <a:cs typeface="맑은 고딕" pitchFamily="34" charset="-120"/>
               </a:rPr>
-              <a:t>NetBackup → NetWorker 전환, 감사/컴플라이언스 대응 위해 시스템 중요도별 백업 보관기간·주기 정책 재정립</a:t>
+              <a:t>plan 노이즈 필터링으로 리뷰어가 실제 변경 리소스만 확인 가능하도록 개선</a:t>
             </a:r>
             <a:endParaRPr lang="en-US" sz="1000" dirty="0"/>
           </a:p>
@@ -8741,7 +8764,7 @@
               <a:buChar char="▪"/>
             </a:pPr>
             <a:r>
-              <a:rPr lang="en-US" sz="1400" dirty="0">
+              <a:rPr lang="en-US" sz="1000" dirty="0">
                 <a:solidFill>
                   <a:srgbClr val="1A1A2E"/>
                 </a:solidFill>
@@ -8749,10 +8772,31 @@
                 <a:ea typeface="맑은 고딕" pitchFamily="34" charset="-122"/>
                 <a:cs typeface="맑은 고딕" pitchFamily="34" charset="-120"/>
               </a:rPr>
-              <a:t>4년간(2021.07~2025.06) 약 500TB, 약 500건 규모 백업 지속 운영</a:t>
+              <a:t>.env 관리 자동화 — git 대신 S3로 분리, 파이프라인 Role에 GetObject만 최소 권한 부여해 plan 실패 문제 해결</a:t>
             </a:r>
             <a:endParaRPr lang="en-US" sz="1000" dirty="0"/>
           </a:p>
+          <a:p>
+            <a:pPr marL="342900" indent="-342900">
+              <a:spcAft>
+                <a:spcPts val="900"/>
+              </a:spcAft>
+              <a:buSzPct val="100000"/>
+              <a:buChar char="▪"/>
+            </a:pPr>
+            <a:r>
+              <a:rPr lang="en-US" sz="1000" dirty="0">
+                <a:solidFill>
+                  <a:srgbClr val="1A1A2E"/>
+                </a:solidFill>
+                <a:latin typeface="맑은 고딕" pitchFamily="34" charset="0"/>
+                <a:ea typeface="맑은 고딕" pitchFamily="34" charset="-122"/>
+                <a:cs typeface="맑은 고딕" pitchFamily="34" charset="-120"/>
+              </a:rPr>
+              <a:t>배포 승인 게이트 — 포탈 승인을 Bitbucket API로 서버가 재검증하는 상태머신 설계, 웹훅 차단 환경은 폴링으로 우회</a:t>
+            </a:r>
+            <a:endParaRPr lang="en-US" sz="1000" dirty="0"/>
+          </a:p>
         </p:txBody>
       </p:sp>
       <p:sp>
@@ -8764,7 +8808,7 @@
         <p:spPr>
           <a:xfrm>
             <a:off x="777240" y="5852160"/>
-            <a:ext cx="10637215" cy="411480"/>
+            <a:ext cx="3027578" cy="411480"/>
           </a:xfrm>
           <a:prstGeom prst="rect">
             <a:avLst/>
@@ -8780,7 +8824,7 @@
               <a:buNone/>
             </a:pPr>
             <a:r>
-              <a:rPr lang="en-US" sz="1200" b="1" dirty="0">
+              <a:rPr lang="en-US" sz="950" b="1" dirty="0">
                 <a:solidFill>
                   <a:srgbClr val="1E2761"/>
                 </a:solidFill>
@@ -8788,7 +8832,7 @@
                 <a:ea typeface="맑은 고딕" pitchFamily="34" charset="-122"/>
                 <a:cs typeface="맑은 고딕" pitchFamily="34" charset="-120"/>
               </a:rPr>
-              <a:t>결과 — 백업·복구 기반 장애 시간 최소화 기여, 감사 대응 백업 정책 표준화</a:t>
+              <a:t>결과 — 무리뷰 배포 구조 차단 및 PR 파이프라인 안정화</a:t>
             </a:r>
             <a:endParaRPr lang="en-US" sz="950" dirty="0"/>
           </a:p>

</xml_diff>

<commit_message>
vault backup: 2026-09-08 15:30:14
</commit_message>
<xml_diff>
--- a/포트폴리오_정상윤_2026_v2.pptx
+++ b/포트폴리오_정상윤_2026_v2.pptx
@@ -5,7 +5,7 @@
     <p:sldMasterId id="2147483648" r:id="rId1"/>
   </p:sldMasterIdLst>
   <p:notesMasterIdLst>
-    <p:notesMasterId r:id="rId12"/>
+    <p:notesMasterId r:id="rId11"/>
   </p:notesMasterIdLst>
   <p:sldIdLst>
     <p:sldId id="256" r:id="rId2"/>
@@ -15,9 +15,9 @@
     <p:sldId id="260" r:id="rId6"/>
     <p:sldId id="261" r:id="rId7"/>
     <p:sldId id="262" r:id="rId8"/>
-    <p:sldId id="266" r:id="rId9"/>
-    <p:sldId id="263" r:id="rId10"/>
-    <p:sldId id="264" r:id="rId11"/>
+    <p:sldId id="266" r:id="rId16"/>
+    <p:sldId id="263" r:id="rId9"/>
+    <p:sldId id="264" r:id="rId10"/>
   </p:sldIdLst>
   <p:sldSz cx="12192000" cy="6858000"/>
   <p:notesSz cx="6858000" cy="12192000"/>
@@ -899,7 +899,7 @@
           <a:p>
             <a:fld id="{F7021451-1387-4CA6-816F-3879F97B5CBC}" type="slidenum">
               <a:rPr lang="en-US"/>
-              <a:t>9</a:t>
+              <a:t>8</a:t>
             </a:fld>
             <a:endParaRPr lang="en-US"/>
           </a:p>
@@ -983,7 +983,7 @@
           <a:p>
             <a:fld id="{F7021451-1387-4CA6-816F-3879F97B5CBC}" type="slidenum">
               <a:rPr lang="en-US"/>
-              <a:t>10</a:t>
+              <a:t>9</a:t>
             </a:fld>
             <a:endParaRPr lang="en-US"/>
           </a:p>
@@ -7555,51 +7555,7 @@
                 <a:ea typeface="맑은 고딕" pitchFamily="34" charset="-122"/>
                 <a:cs typeface="맑은 고딕" pitchFamily="34" charset="-120"/>
               </a:rPr>
-              <a:t>탐지 초기 </a:t>
-            </a:r>
-            <a:r>
-              <a:rPr lang="en-US" sz="1000" dirty="0" err="1">
-                <a:solidFill>
-                  <a:srgbClr val="1A1A2E"/>
-                </a:solidFill>
-                <a:latin typeface="맑은 고딕" pitchFamily="34" charset="0"/>
-                <a:ea typeface="맑은 고딕" pitchFamily="34" charset="-122"/>
-                <a:cs typeface="맑은 고딕" pitchFamily="34" charset="-120"/>
-              </a:rPr>
-              <a:t>노이즈</a:t>
-            </a:r>
-            <a:r>
-              <a:rPr lang="en-US" sz="1000" dirty="0">
-                <a:solidFill>
-                  <a:srgbClr val="1A1A2E"/>
-                </a:solidFill>
-                <a:latin typeface="맑은 고딕" pitchFamily="34" charset="0"/>
-                <a:ea typeface="맑은 고딕" pitchFamily="34" charset="-122"/>
-                <a:cs typeface="맑은 고딕" pitchFamily="34" charset="-120"/>
-              </a:rPr>
-              <a:t>(</a:t>
-            </a:r>
-            <a:r>
-              <a:rPr lang="en-US" sz="1000" dirty="0" err="1">
-                <a:solidFill>
-                  <a:srgbClr val="1A1A2E"/>
-                </a:solidFill>
-                <a:latin typeface="맑은 고딕" pitchFamily="34" charset="0"/>
-                <a:ea typeface="맑은 고딕" pitchFamily="34" charset="-122"/>
-                <a:cs typeface="맑은 고딕" pitchFamily="34" charset="-120"/>
-              </a:rPr>
-              <a:t>오탐</a:t>
-            </a:r>
-            <a:r>
-              <a:rPr lang="en-US" sz="1000" dirty="0">
-                <a:solidFill>
-                  <a:srgbClr val="1A1A2E"/>
-                </a:solidFill>
-                <a:latin typeface="맑은 고딕" pitchFamily="34" charset="0"/>
-                <a:ea typeface="맑은 고딕" pitchFamily="34" charset="-122"/>
-                <a:cs typeface="맑은 고딕" pitchFamily="34" charset="-120"/>
-              </a:rPr>
-              <a:t> 등) 커스텀 룰로 제거 — High 2,725건→0건</a:t>
+              <a:t>탐지 초기 노이즈(veth 오탐 등) 커스텀 룰로 제거 — High 2,725건→0건</a:t>
             </a:r>
             <a:endParaRPr lang="en-US" sz="1000" dirty="0"/>
           </a:p>
@@ -8297,6 +8253,27 @@
                 <a:cs typeface="맑은 고딕" pitchFamily="34" charset="-120"/>
               </a:rPr>
               <a:t>모니터링 알림→슬랙 등록 수동 흐름을 장애 관리 자동화로 전환</a:t>
+            </a:r>
+            <a:endParaRPr lang="en-US" sz="1000" dirty="0"/>
+          </a:p>
+          <a:p>
+            <a:pPr marL="342900" indent="-342900">
+              <a:spcAft>
+                <a:spcPts val="900"/>
+              </a:spcAft>
+              <a:buSzPct val="100000"/>
+              <a:buChar char="▪"/>
+            </a:pPr>
+            <a:r>
+              <a:rPr lang="en-US" sz="1000" dirty="0">
+                <a:solidFill>
+                  <a:srgbClr val="1A1A2E"/>
+                </a:solidFill>
+                <a:latin typeface="맑은 고딕" pitchFamily="34" charset="0"/>
+                <a:ea typeface="맑은 고딕" pitchFamily="34" charset="-122"/>
+                <a:cs typeface="맑은 고딕" pitchFamily="34" charset="-120"/>
+              </a:rPr>
+              <a:t>온프렘 서버 SSH 접근 자동화 — 서버 편입 절차 5단계→4단계 축소, EC2는 SSM·온프렘은 SSH로 실행 경로 분기</a:t>
             </a:r>
             <a:endParaRPr lang="en-US" sz="1000" dirty="0"/>
           </a:p>

</xml_diff>

<commit_message>
vault backup: 2026-09-08 15:55:04
</commit_message>
<xml_diff>
--- a/포트폴리오_정상윤_2026_v2.pptx
+++ b/포트폴리오_정상윤_2026_v2.pptx
@@ -5,7 +5,7 @@
     <p:sldMasterId id="2147483648" r:id="rId1"/>
   </p:sldMasterIdLst>
   <p:notesMasterIdLst>
-    <p:notesMasterId r:id="rId11"/>
+    <p:notesMasterId r:id="rId12"/>
   </p:notesMasterIdLst>
   <p:sldIdLst>
     <p:sldId id="256" r:id="rId2"/>
@@ -15,9 +15,9 @@
     <p:sldId id="260" r:id="rId6"/>
     <p:sldId id="261" r:id="rId7"/>
     <p:sldId id="262" r:id="rId8"/>
-    <p:sldId id="266" r:id="rId16"/>
-    <p:sldId id="263" r:id="rId9"/>
-    <p:sldId id="264" r:id="rId10"/>
+    <p:sldId id="266" r:id="rId9"/>
+    <p:sldId id="263" r:id="rId10"/>
+    <p:sldId id="264" r:id="rId11"/>
   </p:sldIdLst>
   <p:sldSz cx="12192000" cy="6858000"/>
   <p:notesSz cx="6858000" cy="12192000"/>
@@ -899,7 +899,7 @@
           <a:p>
             <a:fld id="{F7021451-1387-4CA6-816F-3879F97B5CBC}" type="slidenum">
               <a:rPr lang="en-US"/>
-              <a:t>8</a:t>
+              <a:t>9</a:t>
             </a:fld>
             <a:endParaRPr lang="en-US"/>
           </a:p>
@@ -983,7 +983,7 @@
           <a:p>
             <a:fld id="{F7021451-1387-4CA6-816F-3879F97B5CBC}" type="slidenum">
               <a:rPr lang="en-US"/>
-              <a:t>9</a:t>
+              <a:t>10</a:t>
             </a:fld>
             <a:endParaRPr lang="en-US"/>
           </a:p>
@@ -7555,7 +7555,7 @@
                 <a:ea typeface="맑은 고딕" pitchFamily="34" charset="-122"/>
                 <a:cs typeface="맑은 고딕" pitchFamily="34" charset="-120"/>
               </a:rPr>
-              <a:t>탐지 초기 노이즈(veth 오탐 등) 커스텀 룰로 제거 — High 2,725건→0건</a:t>
+              <a:t>탐지 초기 노이즈(오탐 등) 커스텀 룰로 제거 — High 2,725건→0건</a:t>
             </a:r>
             <a:endParaRPr lang="en-US" sz="1000" dirty="0"/>
           </a:p>
@@ -8210,7 +8210,7 @@
                 <a:ea typeface="맑은 고딕" pitchFamily="34" charset="-122"/>
                 <a:cs typeface="맑은 고딕" pitchFamily="34" charset="-120"/>
               </a:rPr>
-              <a:t>Keycloak SSO 연동, 신규 서버 편입 시 계정/키 세팅 자동화</a:t>
+              <a:t>Keycloak SSO 연동, 신규 서버 등록 시 계정/키 세팅 자동화</a:t>
             </a:r>
             <a:endParaRPr lang="en-US" sz="1000" dirty="0"/>
           </a:p>
@@ -8273,7 +8273,95 @@
                 <a:ea typeface="맑은 고딕" pitchFamily="34" charset="-122"/>
                 <a:cs typeface="맑은 고딕" pitchFamily="34" charset="-120"/>
               </a:rPr>
-              <a:t>온프렘 서버 SSH 접근 자동화 — 서버 편입 절차 5단계→4단계 축소, EC2는 SSM·온프렘은 SSH로 실행 경로 분기</a:t>
+              <a:t>온프렘 서버 SSH 접근 자동화 — </a:t>
+            </a:r>
+            <a:r>
+              <a:rPr lang="en-US" sz="1000" dirty="0" err="1">
+                <a:solidFill>
+                  <a:srgbClr val="1A1A2E"/>
+                </a:solidFill>
+                <a:latin typeface="맑은 고딕" pitchFamily="34" charset="0"/>
+                <a:ea typeface="맑은 고딕" pitchFamily="34" charset="-122"/>
+                <a:cs typeface="맑은 고딕" pitchFamily="34" charset="-120"/>
+              </a:rPr>
+              <a:t>서버</a:t>
+            </a:r>
+            <a:r>
+              <a:rPr lang="en-US" sz="1000" dirty="0">
+                <a:solidFill>
+                  <a:srgbClr val="1A1A2E"/>
+                </a:solidFill>
+                <a:latin typeface="맑은 고딕" pitchFamily="34" charset="0"/>
+                <a:ea typeface="맑은 고딕" pitchFamily="34" charset="-122"/>
+                <a:cs typeface="맑은 고딕" pitchFamily="34" charset="-120"/>
+              </a:rPr>
+              <a:t> </a:t>
+            </a:r>
+            <a:r>
+              <a:rPr lang="ko-KR" altLang="en-US" sz="1000" dirty="0">
+                <a:solidFill>
+                  <a:srgbClr val="1A1A2E"/>
+                </a:solidFill>
+                <a:latin typeface="맑은 고딕" pitchFamily="34" charset="0"/>
+                <a:ea typeface="맑은 고딕" pitchFamily="34" charset="-122"/>
+                <a:cs typeface="맑은 고딕" pitchFamily="34" charset="-120"/>
+              </a:rPr>
+              <a:t>등록</a:t>
+            </a:r>
+            <a:r>
+              <a:rPr lang="en-US" sz="1000" dirty="0">
+                <a:solidFill>
+                  <a:srgbClr val="1A1A2E"/>
+                </a:solidFill>
+                <a:latin typeface="맑은 고딕" pitchFamily="34" charset="0"/>
+                <a:ea typeface="맑은 고딕" pitchFamily="34" charset="-122"/>
+                <a:cs typeface="맑은 고딕" pitchFamily="34" charset="-120"/>
+              </a:rPr>
+              <a:t> </a:t>
+            </a:r>
+            <a:r>
+              <a:rPr lang="en-US" sz="1000" dirty="0" err="1">
+                <a:solidFill>
+                  <a:srgbClr val="1A1A2E"/>
+                </a:solidFill>
+                <a:latin typeface="맑은 고딕" pitchFamily="34" charset="0"/>
+                <a:ea typeface="맑은 고딕" pitchFamily="34" charset="-122"/>
+                <a:cs typeface="맑은 고딕" pitchFamily="34" charset="-120"/>
+              </a:rPr>
+              <a:t>절차</a:t>
+            </a:r>
+            <a:r>
+              <a:rPr lang="en-US" sz="1000" dirty="0">
+                <a:solidFill>
+                  <a:srgbClr val="1A1A2E"/>
+                </a:solidFill>
+                <a:latin typeface="맑은 고딕" pitchFamily="34" charset="0"/>
+                <a:ea typeface="맑은 고딕" pitchFamily="34" charset="-122"/>
+                <a:cs typeface="맑은 고딕" pitchFamily="34" charset="-120"/>
+              </a:rPr>
+              <a:t> </a:t>
+            </a:r>
+            <a:r>
+              <a:rPr lang="ko-KR" altLang="en-US" sz="1000" dirty="0">
+                <a:solidFill>
+                  <a:srgbClr val="1A1A2E"/>
+                </a:solidFill>
+                <a:latin typeface="맑은 고딕" pitchFamily="34" charset="0"/>
+                <a:ea typeface="맑은 고딕" pitchFamily="34" charset="-122"/>
+                <a:cs typeface="맑은 고딕" pitchFamily="34" charset="-120"/>
+              </a:rPr>
+              <a:t>구현</a:t>
+            </a:r>
+            <a:r>
+              <a:rPr lang="en-US" sz="1000" dirty="0">
+                <a:solidFill>
+                  <a:srgbClr val="1A1A2E"/>
+                </a:solidFill>
+                <a:latin typeface="맑은 고딕" pitchFamily="34" charset="0"/>
+                <a:ea typeface="맑은 고딕" pitchFamily="34" charset="-122"/>
+                <a:cs typeface="맑은 고딕" pitchFamily="34" charset="-120"/>
+              </a:rPr>
+              <a:t>, EC2는 SSM·온프렘은 SSH로 실행 경로 분기</a:t>
             </a:r>
             <a:endParaRPr lang="en-US" sz="1000" dirty="0"/>
           </a:p>

</xml_diff>

<commit_message>
vault backup: 2026-09-09 14:34:37
</commit_message>
<xml_diff>
--- a/포트폴리오_정상윤_2026_v2.pptx
+++ b/포트폴리오_정상윤_2026_v2.pptx
@@ -8123,6 +8123,344 @@
                 <a:cs typeface="맑은 고딕" pitchFamily="34" charset="-120"/>
               </a:rPr>
               <a:t>결과 — 백업·복구 기반 장애 시간 최소화 기여, 감사 대응 백업 정책 표준화</a:t>
+            </a:r>
+            <a:endParaRPr lang="en-US" sz="950" dirty="0"/>
+          </a:p>
+        </p:txBody>
+      </p:sp>
+      <p:sp>
+        <p:nvSpPr>
+          <p:cNvPr id="13" name="Shape 11"/>
+          <p:cNvSpPr/>
+          <p:nvPr/>
+        </p:nvSpPr>
+        <p:spPr>
+          <a:xfrm>
+            <a:off x="4353458" y="1188720"/>
+            <a:ext cx="3484778" cy="5166360"/>
+          </a:xfrm>
+          <a:prstGeom prst="roundRect">
+            <a:avLst>
+              <a:gd name="adj" fmla="val 2099"/>
+            </a:avLst>
+          </a:prstGeom>
+          <a:solidFill>
+            <a:srgbClr val="F1F5FC"/>
+          </a:solidFill>
+          <a:ln w="12700">
+            <a:solidFill>
+              <a:srgbClr val="D8E3F5"/>
+            </a:solidFill>
+            <a:prstDash val="solid"/>
+          </a:ln>
+          <a:effectLst>
+            <a:outerShdw blurRad="76200" dist="25400" dir="5400000" algn="bl" rotWithShape="0">
+              <a:srgbClr val="1E2761">
+                <a:alpha val="12000"/>
+              </a:srgbClr>
+            </a:outerShdw>
+          </a:effectLst>
+        </p:spPr>
+        <p:txBody>
+          <a:bodyPr/>
+          <a:lstStyle/>
+          <a:p>
+            <a:endParaRPr lang="ko-KR" altLang="en-US"/>
+          </a:p>
+        </p:txBody>
+      </p:sp>
+      <p:sp>
+        <p:nvSpPr>
+          <p:cNvPr id="14" name="Shape 12"/>
+          <p:cNvSpPr/>
+          <p:nvPr/>
+        </p:nvSpPr>
+        <p:spPr>
+          <a:xfrm>
+            <a:off x="4353458" y="1188720"/>
+            <a:ext cx="3484778" cy="457200"/>
+          </a:xfrm>
+          <a:prstGeom prst="roundRect">
+            <a:avLst>
+              <a:gd name="adj" fmla="val 16000"/>
+            </a:avLst>
+          </a:prstGeom>
+          <a:solidFill>
+            <a:srgbClr val="1E2761"/>
+          </a:solidFill>
+          <a:ln/>
+        </p:spPr>
+        <p:txBody>
+          <a:bodyPr/>
+          <a:lstStyle/>
+          <a:p>
+            <a:endParaRPr lang="ko-KR" altLang="en-US"/>
+          </a:p>
+        </p:txBody>
+      </p:sp>
+      <p:sp>
+        <p:nvSpPr>
+          <p:cNvPr id="15" name="Shape 13"/>
+          <p:cNvSpPr/>
+          <p:nvPr/>
+        </p:nvSpPr>
+        <p:spPr>
+          <a:xfrm>
+            <a:off x="4353458" y="1417320"/>
+            <a:ext cx="3484778" cy="228600"/>
+          </a:xfrm>
+          <a:prstGeom prst="rect">
+            <a:avLst/>
+          </a:prstGeom>
+          <a:solidFill>
+            <a:srgbClr val="1E2761"/>
+          </a:solidFill>
+          <a:ln/>
+        </p:spPr>
+        <p:txBody>
+          <a:bodyPr/>
+          <a:lstStyle/>
+          <a:p>
+            <a:endParaRPr lang="ko-KR" altLang="en-US"/>
+          </a:p>
+        </p:txBody>
+      </p:sp>
+      <p:sp>
+        <p:nvSpPr>
+          <p:cNvPr id="16" name="Text 14"/>
+          <p:cNvSpPr/>
+          <p:nvPr/>
+        </p:nvSpPr>
+        <p:spPr>
+          <a:xfrm>
+            <a:off x="4536338" y="1188720"/>
+            <a:ext cx="3119018" cy="457200"/>
+          </a:xfrm>
+          <a:prstGeom prst="rect">
+            <a:avLst/>
+          </a:prstGeom>
+          <a:noFill/>
+          <a:ln/>
+        </p:spPr>
+        <p:txBody>
+          <a:bodyPr wrap="square" rtlCol="0" anchor="ctr"/>
+          <a:lstStyle/>
+          <a:p>
+            <a:pPr marL="0" indent="0">
+              <a:buNone/>
+            </a:pPr>
+            <a:r>
+              <a:rPr lang="en-US" sz="950" b="1" dirty="0">
+                <a:solidFill>
+                  <a:srgbClr val="CADCFC"/>
+                </a:solidFill>
+                <a:latin typeface="맑은 고딕" pitchFamily="34" charset="0"/>
+                <a:ea typeface="맑은 고딕" pitchFamily="34" charset="-122"/>
+                <a:cs typeface="맑은 고딕" pitchFamily="34" charset="-120"/>
+              </a:rPr>
+              <a:t>AK아이에스</a:t>
+            </a:r>
+            <a:endParaRPr lang="en-US" sz="950" dirty="0"/>
+          </a:p>
+        </p:txBody>
+      </p:sp>
+      <p:sp>
+        <p:nvSpPr>
+          <p:cNvPr id="17" name="Text 15"/>
+          <p:cNvSpPr/>
+          <p:nvPr/>
+        </p:nvSpPr>
+        <p:spPr>
+          <a:xfrm>
+            <a:off x="4536338" y="1188720"/>
+            <a:ext cx="3119018" cy="457200"/>
+          </a:xfrm>
+          <a:prstGeom prst="rect">
+            <a:avLst/>
+          </a:prstGeom>
+          <a:noFill/>
+          <a:ln/>
+        </p:spPr>
+        <p:txBody>
+          <a:bodyPr wrap="square" rtlCol="0" anchor="ctr"/>
+          <a:lstStyle/>
+          <a:p>
+            <a:pPr marL="0" indent="0" algn="r">
+              <a:buNone/>
+            </a:pPr>
+            <a:r>
+              <a:rPr lang="en-US" sz="950" b="1" dirty="0">
+                <a:solidFill>
+                  <a:srgbClr val="FFFFFF"/>
+                </a:solidFill>
+                <a:latin typeface="맑은 고딕" pitchFamily="34" charset="0"/>
+                <a:ea typeface="맑은 고딕" pitchFamily="34" charset="-122"/>
+                <a:cs typeface="맑은 고딕" pitchFamily="34" charset="-120"/>
+              </a:rPr>
+              <a:t>2025.05~2025.06</a:t>
+            </a:r>
+            <a:endParaRPr lang="en-US" sz="950" dirty="0"/>
+          </a:p>
+        </p:txBody>
+      </p:sp>
+      <p:sp>
+        <p:nvSpPr>
+          <p:cNvPr id="18" name="Text 16"/>
+          <p:cNvSpPr/>
+          <p:nvPr/>
+        </p:nvSpPr>
+        <p:spPr>
+          <a:xfrm>
+            <a:off x="4582058" y="1783080"/>
+            <a:ext cx="3027578" cy="640080"/>
+          </a:xfrm>
+          <a:prstGeom prst="rect">
+            <a:avLst/>
+          </a:prstGeom>
+          <a:noFill/>
+          <a:ln/>
+        </p:spPr>
+        <p:txBody>
+          <a:bodyPr wrap="square" rtlCol="0" anchor="t"/>
+          <a:lstStyle/>
+          <a:p>
+            <a:pPr marL="0" indent="0">
+              <a:buNone/>
+            </a:pPr>
+            <a:r>
+              <a:rPr lang="en-US" sz="1400" b="1" dirty="0">
+                <a:solidFill>
+                  <a:srgbClr val="1E2761"/>
+                </a:solidFill>
+                <a:latin typeface="맑은 고딕" pitchFamily="34" charset="0"/>
+                <a:ea typeface="맑은 고딕" pitchFamily="34" charset="-122"/>
+                <a:cs typeface="맑은 고딕" pitchFamily="34" charset="-120"/>
+              </a:rPr>
+              <a:t>CDN 이관 (Akamai → CloudFront)</a:t>
+            </a:r>
+            <a:endParaRPr lang="en-US" sz="1400" dirty="0"/>
+          </a:p>
+        </p:txBody>
+      </p:sp>
+      <p:sp>
+        <p:nvSpPr>
+          <p:cNvPr id="19" name="Text 17"/>
+          <p:cNvSpPr/>
+          <p:nvPr/>
+        </p:nvSpPr>
+        <p:spPr>
+          <a:xfrm>
+            <a:off x="4582058" y="2514600"/>
+            <a:ext cx="3027578" cy="3429000"/>
+          </a:xfrm>
+          <a:prstGeom prst="rect">
+            <a:avLst/>
+          </a:prstGeom>
+          <a:noFill/>
+          <a:ln/>
+        </p:spPr>
+        <p:txBody>
+          <a:bodyPr wrap="square" rtlCol="0" anchor="t"/>
+          <a:lstStyle/>
+          <a:p>
+            <a:pPr marL="342900" indent="-342900">
+              <a:spcAft>
+                <a:spcPts val="900"/>
+              </a:spcAft>
+              <a:buSzPct val="100000"/>
+              <a:buChar char="▪"/>
+            </a:pPr>
+            <a:r>
+              <a:rPr lang="en-US" sz="1000" dirty="0">
+                <a:solidFill>
+                  <a:srgbClr val="1A1A2E"/>
+                </a:solidFill>
+                <a:latin typeface="맑은 고딕" pitchFamily="34" charset="0"/>
+                <a:ea typeface="맑은 고딕" pitchFamily="34" charset="-122"/>
+                <a:cs typeface="맑은 고딕" pitchFamily="34" charset="-120"/>
+              </a:rPr>
+              <a:t>Akamai 라이선스 비용 부담으로 CloudFront 전환, Route53 가중치 기반 단계적 트래픽 이관으로 리스크 최소화</a:t>
+            </a:r>
+            <a:endParaRPr lang="en-US" sz="1000" dirty="0"/>
+          </a:p>
+          <a:p>
+            <a:pPr marL="342900" indent="-342900">
+              <a:spcAft>
+                <a:spcPts val="900"/>
+              </a:spcAft>
+              <a:buSzPct val="100000"/>
+              <a:buChar char="▪"/>
+            </a:pPr>
+            <a:r>
+              <a:rPr lang="en-US" sz="1000" dirty="0">
+                <a:solidFill>
+                  <a:srgbClr val="1A1A2E"/>
+                </a:solidFill>
+                <a:latin typeface="맑은 고딕" pitchFamily="34" charset="0"/>
+                <a:ea typeface="맑은 고딕" pitchFamily="34" charset="-122"/>
+                <a:cs typeface="맑은 고딕" pitchFamily="34" charset="-120"/>
+              </a:rPr>
+              <a:t>Akamai Edge 규칙(리다이렉션, 헤더 조작, 이미지 최적화)을 Lambda@Edge로 재구현해 기능 연속성 확보</a:t>
+            </a:r>
+            <a:endParaRPr lang="en-US" sz="1000" dirty="0"/>
+          </a:p>
+          <a:p>
+            <a:pPr marL="342900" indent="-342900">
+              <a:spcAft>
+                <a:spcPts val="900"/>
+              </a:spcAft>
+              <a:buSzPct val="100000"/>
+              <a:buChar char="▪"/>
+            </a:pPr>
+            <a:r>
+              <a:rPr lang="en-US" sz="1000" dirty="0">
+                <a:solidFill>
+                  <a:srgbClr val="1A1A2E"/>
+                </a:solidFill>
+                <a:latin typeface="맑은 고딕" pitchFamily="34" charset="0"/>
+                <a:ea typeface="맑은 고딕" pitchFamily="34" charset="-122"/>
+                <a:cs typeface="맑은 고딕" pitchFamily="34" charset="-120"/>
+              </a:rPr>
+              <a:t>CloudWatch·Athena 로그 분석으로 국가별 Latency·Cache Hit Ratio 최적화</a:t>
+            </a:r>
+            <a:endParaRPr lang="en-US" sz="1000" dirty="0"/>
+          </a:p>
+        </p:txBody>
+      </p:sp>
+      <p:sp>
+        <p:nvSpPr>
+          <p:cNvPr id="20" name="Text 18"/>
+          <p:cNvSpPr/>
+          <p:nvPr/>
+        </p:nvSpPr>
+        <p:spPr>
+          <a:xfrm>
+            <a:off x="4582058" y="5852160"/>
+            <a:ext cx="3027578" cy="411480"/>
+          </a:xfrm>
+          <a:prstGeom prst="rect">
+            <a:avLst/>
+          </a:prstGeom>
+          <a:noFill/>
+          <a:ln/>
+        </p:spPr>
+        <p:txBody>
+          <a:bodyPr wrap="square" rtlCol="0" anchor="ctr"/>
+          <a:lstStyle/>
+          <a:p>
+            <a:pPr marL="0" indent="0">
+              <a:buNone/>
+            </a:pPr>
+            <a:r>
+              <a:rPr lang="en-US" sz="950" b="1" dirty="0">
+                <a:solidFill>
+                  <a:srgbClr val="1E2761"/>
+                </a:solidFill>
+                <a:latin typeface="맑은 고딕" pitchFamily="34" charset="0"/>
+                <a:ea typeface="맑은 고딕" pitchFamily="34" charset="-122"/>
+                <a:cs typeface="맑은 고딕" pitchFamily="34" charset="-120"/>
+              </a:rPr>
+              <a:t>결과 — 월 운영비용 약 15% 절감, 무중단 전환</a:t>
             </a:r>
             <a:endParaRPr lang="en-US" sz="950" dirty="0"/>
           </a:p>

</xml_diff>

<commit_message>
vault backup: 2026-09-09 14:54:40
</commit_message>
<xml_diff>
--- a/포트폴리오_정상윤_2026_v2.pptx
+++ b/포트폴리오_정상윤_2026_v2.pptx
@@ -8461,6 +8461,344 @@
                 <a:cs typeface="맑은 고딕" pitchFamily="34" charset="-120"/>
               </a:rPr>
               <a:t>결과 — 월 운영비용 약 15% 절감, 무중단 전환</a:t>
+            </a:r>
+            <a:endParaRPr lang="en-US" sz="950" dirty="0"/>
+          </a:p>
+        </p:txBody>
+      </p:sp>
+      <p:sp>
+        <p:nvSpPr>
+          <p:cNvPr id="21" name="Shape 19"/>
+          <p:cNvSpPr/>
+          <p:nvPr/>
+        </p:nvSpPr>
+        <p:spPr>
+          <a:xfrm>
+            <a:off x="8158277" y="1188720"/>
+            <a:ext cx="3484778" cy="5166360"/>
+          </a:xfrm>
+          <a:prstGeom prst="roundRect">
+            <a:avLst>
+              <a:gd name="adj" fmla="val 2099"/>
+            </a:avLst>
+          </a:prstGeom>
+          <a:solidFill>
+            <a:srgbClr val="F1F5FC"/>
+          </a:solidFill>
+          <a:ln w="12700">
+            <a:solidFill>
+              <a:srgbClr val="D8E3F5"/>
+            </a:solidFill>
+            <a:prstDash val="solid"/>
+          </a:ln>
+          <a:effectLst>
+            <a:outerShdw blurRad="76200" dist="25400" dir="5400000" algn="bl" rotWithShape="0">
+              <a:srgbClr val="1E2761">
+                <a:alpha val="12000"/>
+              </a:srgbClr>
+            </a:outerShdw>
+          </a:effectLst>
+        </p:spPr>
+        <p:txBody>
+          <a:bodyPr/>
+          <a:lstStyle/>
+          <a:p>
+            <a:endParaRPr lang="ko-KR" altLang="en-US"/>
+          </a:p>
+        </p:txBody>
+      </p:sp>
+      <p:sp>
+        <p:nvSpPr>
+          <p:cNvPr id="22" name="Shape 20"/>
+          <p:cNvSpPr/>
+          <p:nvPr/>
+        </p:nvSpPr>
+        <p:spPr>
+          <a:xfrm>
+            <a:off x="8158277" y="1188720"/>
+            <a:ext cx="3484778" cy="457200"/>
+          </a:xfrm>
+          <a:prstGeom prst="roundRect">
+            <a:avLst>
+              <a:gd name="adj" fmla="val 16000"/>
+            </a:avLst>
+          </a:prstGeom>
+          <a:solidFill>
+            <a:srgbClr val="1E2761"/>
+          </a:solidFill>
+          <a:ln/>
+        </p:spPr>
+        <p:txBody>
+          <a:bodyPr/>
+          <a:lstStyle/>
+          <a:p>
+            <a:endParaRPr lang="ko-KR" altLang="en-US"/>
+          </a:p>
+        </p:txBody>
+      </p:sp>
+      <p:sp>
+        <p:nvSpPr>
+          <p:cNvPr id="23" name="Shape 21"/>
+          <p:cNvSpPr/>
+          <p:nvPr/>
+        </p:nvSpPr>
+        <p:spPr>
+          <a:xfrm>
+            <a:off x="8158277" y="1417320"/>
+            <a:ext cx="3484778" cy="228600"/>
+          </a:xfrm>
+          <a:prstGeom prst="rect">
+            <a:avLst/>
+          </a:prstGeom>
+          <a:solidFill>
+            <a:srgbClr val="1E2761"/>
+          </a:solidFill>
+          <a:ln/>
+        </p:spPr>
+        <p:txBody>
+          <a:bodyPr/>
+          <a:lstStyle/>
+          <a:p>
+            <a:endParaRPr lang="ko-KR" altLang="en-US"/>
+          </a:p>
+        </p:txBody>
+      </p:sp>
+      <p:sp>
+        <p:nvSpPr>
+          <p:cNvPr id="24" name="Text 22"/>
+          <p:cNvSpPr/>
+          <p:nvPr/>
+        </p:nvSpPr>
+        <p:spPr>
+          <a:xfrm>
+            <a:off x="8341157" y="1188720"/>
+            <a:ext cx="3119018" cy="457200"/>
+          </a:xfrm>
+          <a:prstGeom prst="rect">
+            <a:avLst/>
+          </a:prstGeom>
+          <a:noFill/>
+          <a:ln/>
+        </p:spPr>
+        <p:txBody>
+          <a:bodyPr wrap="square" rtlCol="0" anchor="ctr"/>
+          <a:lstStyle/>
+          <a:p>
+            <a:pPr marL="0" indent="0">
+              <a:buNone/>
+            </a:pPr>
+            <a:r>
+              <a:rPr lang="en-US" sz="950" b="1" dirty="0">
+                <a:solidFill>
+                  <a:srgbClr val="CADCFC"/>
+                </a:solidFill>
+                <a:latin typeface="맑은 고딕" pitchFamily="34" charset="0"/>
+                <a:ea typeface="맑은 고딕" pitchFamily="34" charset="-122"/>
+                <a:cs typeface="맑은 고딕" pitchFamily="34" charset="-120"/>
+              </a:rPr>
+              <a:t>AK아이에스</a:t>
+            </a:r>
+            <a:endParaRPr lang="en-US" sz="950" dirty="0"/>
+          </a:p>
+        </p:txBody>
+      </p:sp>
+      <p:sp>
+        <p:nvSpPr>
+          <p:cNvPr id="25" name="Text 23"/>
+          <p:cNvSpPr/>
+          <p:nvPr/>
+        </p:nvSpPr>
+        <p:spPr>
+          <a:xfrm>
+            <a:off x="8341157" y="1188720"/>
+            <a:ext cx="3119018" cy="457200"/>
+          </a:xfrm>
+          <a:prstGeom prst="rect">
+            <a:avLst/>
+          </a:prstGeom>
+          <a:noFill/>
+          <a:ln/>
+        </p:spPr>
+        <p:txBody>
+          <a:bodyPr wrap="square" rtlCol="0" anchor="ctr"/>
+          <a:lstStyle/>
+          <a:p>
+            <a:pPr marL="0" indent="0" algn="r">
+              <a:buNone/>
+            </a:pPr>
+            <a:r>
+              <a:rPr lang="en-US" sz="950" b="1" dirty="0">
+                <a:solidFill>
+                  <a:srgbClr val="FFFFFF"/>
+                </a:solidFill>
+                <a:latin typeface="맑은 고딕" pitchFamily="34" charset="0"/>
+                <a:ea typeface="맑은 고딕" pitchFamily="34" charset="-122"/>
+                <a:cs typeface="맑은 고딕" pitchFamily="34" charset="-120"/>
+              </a:rPr>
+              <a:t>2023.10~2024.03</a:t>
+            </a:r>
+            <a:endParaRPr lang="en-US" sz="950" dirty="0"/>
+          </a:p>
+        </p:txBody>
+      </p:sp>
+      <p:sp>
+        <p:nvSpPr>
+          <p:cNvPr id="26" name="Text 24"/>
+          <p:cNvSpPr/>
+          <p:nvPr/>
+        </p:nvSpPr>
+        <p:spPr>
+          <a:xfrm>
+            <a:off x="8386877" y="1783080"/>
+            <a:ext cx="3027578" cy="640080"/>
+          </a:xfrm>
+          <a:prstGeom prst="rect">
+            <a:avLst/>
+          </a:prstGeom>
+          <a:noFill/>
+          <a:ln/>
+        </p:spPr>
+        <p:txBody>
+          <a:bodyPr wrap="square" rtlCol="0" anchor="t"/>
+          <a:lstStyle/>
+          <a:p>
+            <a:pPr marL="0" indent="0">
+              <a:buNone/>
+            </a:pPr>
+            <a:r>
+              <a:rPr lang="en-US" sz="1400" b="1" dirty="0">
+                <a:solidFill>
+                  <a:srgbClr val="1E2761"/>
+                </a:solidFill>
+                <a:latin typeface="맑은 고딕" pitchFamily="34" charset="0"/>
+                <a:ea typeface="맑은 고딕" pitchFamily="34" charset="-122"/>
+                <a:cs typeface="맑은 고딕" pitchFamily="34" charset="-120"/>
+              </a:rPr>
+              <a:t>운송통합시스템 구축</a:t>
+            </a:r>
+            <a:endParaRPr lang="en-US" sz="1400" dirty="0"/>
+          </a:p>
+        </p:txBody>
+      </p:sp>
+      <p:sp>
+        <p:nvSpPr>
+          <p:cNvPr id="27" name="Text 25"/>
+          <p:cNvSpPr/>
+          <p:nvPr/>
+        </p:nvSpPr>
+        <p:spPr>
+          <a:xfrm>
+            <a:off x="8386877" y="2514600"/>
+            <a:ext cx="3027578" cy="3429000"/>
+          </a:xfrm>
+          <a:prstGeom prst="rect">
+            <a:avLst/>
+          </a:prstGeom>
+          <a:noFill/>
+          <a:ln/>
+        </p:spPr>
+        <p:txBody>
+          <a:bodyPr wrap="square" rtlCol="0" anchor="t"/>
+          <a:lstStyle/>
+          <a:p>
+            <a:pPr marL="342900" indent="-342900">
+              <a:spcAft>
+                <a:spcPts val="900"/>
+              </a:spcAft>
+              <a:buSzPct val="100000"/>
+              <a:buChar char="▪"/>
+            </a:pPr>
+            <a:r>
+              <a:rPr lang="en-US" sz="1000" dirty="0">
+                <a:solidFill>
+                  <a:srgbClr val="1A1A2E"/>
+                </a:solidFill>
+                <a:latin typeface="맑은 고딕" pitchFamily="34" charset="0"/>
+                <a:ea typeface="맑은 고딕" pitchFamily="34" charset="-122"/>
+                <a:cs typeface="맑은 고딕" pitchFamily="34" charset="-120"/>
+              </a:rPr>
+              <a:t>Nutanix 장비 구축 및 펌웨어 업데이트, 네트워크/VM 구성</a:t>
+            </a:r>
+            <a:endParaRPr lang="en-US" sz="1000" dirty="0"/>
+          </a:p>
+          <a:p>
+            <a:pPr marL="342900" indent="-342900">
+              <a:spcAft>
+                <a:spcPts val="900"/>
+              </a:spcAft>
+              <a:buSzPct val="100000"/>
+              <a:buChar char="▪"/>
+            </a:pPr>
+            <a:r>
+              <a:rPr lang="en-US" sz="1000" dirty="0">
+                <a:solidFill>
+                  <a:srgbClr val="1A1A2E"/>
+                </a:solidFill>
+                <a:latin typeface="맑은 고딕" pitchFamily="34" charset="0"/>
+                <a:ea typeface="맑은 고딕" pitchFamily="34" charset="-122"/>
+                <a:cs typeface="맑은 고딕" pitchFamily="34" charset="-120"/>
+              </a:rPr>
+              <a:t>LENA WEB/WAS 구성 및 OS 보안조치</a:t>
+            </a:r>
+            <a:endParaRPr lang="en-US" sz="1000" dirty="0"/>
+          </a:p>
+          <a:p>
+            <a:pPr marL="342900" indent="-342900">
+              <a:spcAft>
+                <a:spcPts val="900"/>
+              </a:spcAft>
+              <a:buSzPct val="100000"/>
+              <a:buChar char="▪"/>
+            </a:pPr>
+            <a:r>
+              <a:rPr lang="en-US" sz="1000" dirty="0">
+                <a:solidFill>
+                  <a:srgbClr val="1A1A2E"/>
+                </a:solidFill>
+                <a:latin typeface="맑은 고딕" pitchFamily="34" charset="0"/>
+                <a:ea typeface="맑은 고딕" pitchFamily="34" charset="-122"/>
+                <a:cs typeface="맑은 고딕" pitchFamily="34" charset="-120"/>
+              </a:rPr>
+              <a:t>APM(TunA) Transaction Trace 기반 트랜잭션 로그 분석으로 병목 구간·Memory Leak 포인트 파악 및 사전 제거</a:t>
+            </a:r>
+            <a:endParaRPr lang="en-US" sz="1000" dirty="0"/>
+          </a:p>
+        </p:txBody>
+      </p:sp>
+      <p:sp>
+        <p:nvSpPr>
+          <p:cNvPr id="28" name="Text 26"/>
+          <p:cNvSpPr/>
+          <p:nvPr/>
+        </p:nvSpPr>
+        <p:spPr>
+          <a:xfrm>
+            <a:off x="8386877" y="5852160"/>
+            <a:ext cx="3027578" cy="411480"/>
+          </a:xfrm>
+          <a:prstGeom prst="rect">
+            <a:avLst/>
+          </a:prstGeom>
+          <a:noFill/>
+          <a:ln/>
+        </p:spPr>
+        <p:txBody>
+          <a:bodyPr wrap="square" rtlCol="0" anchor="ctr"/>
+          <a:lstStyle/>
+          <a:p>
+            <a:pPr marL="0" indent="0">
+              <a:buNone/>
+            </a:pPr>
+            <a:r>
+              <a:rPr lang="en-US" sz="950" b="1" dirty="0">
+                <a:solidFill>
+                  <a:srgbClr val="1E2761"/>
+                </a:solidFill>
+                <a:latin typeface="맑은 고딕" pitchFamily="34" charset="0"/>
+                <a:ea typeface="맑은 고딕" pitchFamily="34" charset="-122"/>
+                <a:cs typeface="맑은 고딕" pitchFamily="34" charset="-120"/>
+              </a:rPr>
+              <a:t>결과 — 안정적인 운송통합시스템 전환, TunA 기반 사전 진단으로 장애 예방</a:t>
             </a:r>
             <a:endParaRPr lang="en-US" sz="950" dirty="0"/>
           </a:p>

</xml_diff>

<commit_message>
vault backup: 2026-09-09 15:04:43
</commit_message>
<xml_diff>
--- a/포트폴리오_정상윤_2026_v2.pptx
+++ b/포트폴리오_정상윤_2026_v2.pptx
@@ -4879,7 +4879,7 @@
                 <a:ea typeface="맑은 고딕" pitchFamily="34" charset="-122"/>
                 <a:cs typeface="맑은 고딕" pitchFamily="34" charset="-120"/>
               </a:rPr>
-              <a:t>build-test-ECR push-배포승인-deploy 멀티스테이지 파이프라인 설계</a:t>
+              <a:t>ECR push·Pod 배포까지의 멀티스테이지 파이프라인 설계</a:t>
             </a:r>
             <a:endParaRPr lang="en-US" sz="950" dirty="0"/>
           </a:p>
@@ -6931,7 +6931,7 @@
                 <a:ea typeface="맑은 고딕" pitchFamily="34" charset="-122"/>
                 <a:cs typeface="맑은 고딕" pitchFamily="34" charset="-120"/>
               </a:rPr>
-              <a:t>ELK 통합 로그, NLB/ALB 계층별 트래픽 분산 설계</a:t>
+              <a:t>ELK·Kibana 기반 통합 로그 관제, NLB/ALB 계층별 트래픽 분산 설계</a:t>
             </a:r>
             <a:endParaRPr lang="en-US" sz="1000" dirty="0"/>
           </a:p>
@@ -8041,7 +8041,7 @@
                 <a:ea typeface="맑은 고딕" pitchFamily="34" charset="-122"/>
                 <a:cs typeface="맑은 고딕" pitchFamily="34" charset="-120"/>
               </a:rPr>
-              <a:t>EKS 전환으로 드러난 백업 체계 공백 확인, 온프렘 통합로그 서버 구축 및 ELK 설정</a:t>
+              <a:t>EKS 전환으로 드러난 백업 체계 공백 확인, 온프렘 통합로그 서버 구축 및 ELK·Kibana 설정</a:t>
             </a:r>
             <a:endParaRPr lang="en-US" sz="1000" dirty="0"/>
           </a:p>

</xml_diff>

<commit_message>
vault backup: 2026-09-10 12:26:55
</commit_message>
<xml_diff>
--- a/포트폴리오_정상윤_2026_v2.pptx
+++ b/포트폴리오_정상윤_2026_v2.pptx
@@ -3691,7 +3691,7 @@
                 <a:ea typeface="맑은 고딕" pitchFamily="34" charset="-122"/>
                 <a:cs typeface="맑은 고딕" pitchFamily="34" charset="-120"/>
               </a:rPr>
-              <a:t>대신증권·삼성카드·KB그룹 등 금융권 IDC 이전 프로젝트 다수 수행</a:t>
+              <a:t>대신저축은행·KB그룹 등 금융권 IDC 이전 프로젝트 다수 수행</a:t>
             </a:r>
             <a:endParaRPr lang="en-US" sz="1050" dirty="0"/>
           </a:p>
@@ -7565,7 +7565,7 @@
                 <a:ea typeface="맑은 고딕" pitchFamily="34" charset="-122"/>
                 <a:cs typeface="맑은 고딕" pitchFamily="34" charset="-120"/>
               </a:rPr>
-              <a:t>이벤트 트래픽 폭증으로 CPU 부하·DB 커넥션 고갈, 서비스 중단 발생</a:t>
+              <a:t>"찜" 이벤트 당시 동접 약 30만 명 트래픽 폭증으로 CPU 부하·DB 커넥션 고갈, 서비스 중단 발생</a:t>
             </a:r>
             <a:endParaRPr lang="en-US" sz="1000" dirty="0"/>
           </a:p>
@@ -10746,7 +10746,7 @@
                 <a:ea typeface="맑은 고딕" pitchFamily="34" charset="-122"/>
                 <a:cs typeface="맑은 고딕" pitchFamily="34" charset="-120"/>
               </a:rPr>
-              <a:t>Sentry 애플리케이션 에러 트래킹 도입, satchat/Keycloak 서비스별 Slack 알림 채널 분리</a:t>
+              <a:t>Sentry 애플리케이션 에러 트래킹 도입, coreservice/Keycloak 서비스별 Slack 알림 채널 분리</a:t>
             </a:r>
             <a:endParaRPr lang="en-US" sz="1000" dirty="0"/>
           </a:p>

</xml_diff>

<commit_message>
vault backup: 2026-09-11 10:21:26
</commit_message>
<xml_diff>
--- a/포트폴리오_정상윤_2026_v2.pptx
+++ b/포트폴리오_정상윤_2026_v2.pptx
@@ -15,6 +15,7 @@
     <p:sldId id="260" r:id="rId6"/>
     <p:sldId id="261" r:id="rId7"/>
     <p:sldId id="267" r:id="rId17"/>
+    <p:sldId id="268" r:id="rId18"/>
     <p:sldId id="262" r:id="rId8"/>
     <p:sldId id="266" r:id="rId9"/>
     <p:sldId id="263" r:id="rId10"/>
@@ -2797,6 +2798,503 @@
 </p:sld>
 </file>
 
+<file path=ppt/slides/slide12.xml><?xml version="1.0" encoding="utf-8"?>
+<p:sld xmlns:a="http://schemas.openxmlformats.org/drawingml/2006/main" xmlns:r="http://schemas.openxmlformats.org/officeDocument/2006/relationships" xmlns:p="http://schemas.openxmlformats.org/presentationml/2006/main">
+  <p:cSld name="Slide 6">
+    <p:bg>
+      <p:bgPr>
+        <a:solidFill>
+          <a:srgbClr val="FFFFFF"/>
+        </a:solidFill>
+        <a:effectLst/>
+      </p:bgPr>
+    </p:bg>
+    <p:spTree>
+      <p:nvGrpSpPr>
+        <p:cNvPr id="1" name=""/>
+        <p:cNvGrpSpPr/>
+        <p:nvPr/>
+      </p:nvGrpSpPr>
+      <p:grpSpPr>
+        <a:xfrm>
+          <a:off x="0" y="0"/>
+          <a:ext cx="0" cy="0"/>
+          <a:chOff x="0" y="0"/>
+          <a:chExt cx="0" cy="0"/>
+        </a:xfrm>
+      </p:grpSpPr>
+      <p:sp>
+        <p:nvSpPr>
+          <p:cNvPr id="2" name="Shape 0"/>
+          <p:cNvSpPr/>
+          <p:nvPr/>
+        </p:nvSpPr>
+        <p:spPr>
+          <a:xfrm>
+            <a:off x="0" y="0"/>
+            <a:ext cx="12191695" cy="914400"/>
+          </a:xfrm>
+          <a:prstGeom prst="rect">
+            <a:avLst/>
+          </a:prstGeom>
+          <a:solidFill>
+            <a:srgbClr val="1E2761"/>
+          </a:solidFill>
+          <a:ln/>
+        </p:spPr>
+        <p:txBody>
+          <a:bodyPr/>
+          <a:lstStyle/>
+          <a:p>
+            <a:endParaRPr lang="ko-KR" altLang="en-US"/>
+          </a:p>
+        </p:txBody>
+      </p:sp>
+      <p:sp>
+        <p:nvSpPr>
+          <p:cNvPr id="3" name="Text 1"/>
+          <p:cNvSpPr/>
+          <p:nvPr/>
+        </p:nvSpPr>
+        <p:spPr>
+          <a:xfrm>
+            <a:off x="548640" y="164592"/>
+            <a:ext cx="4200000" cy="320040"/>
+          </a:xfrm>
+          <a:prstGeom prst="rect">
+            <a:avLst/>
+          </a:prstGeom>
+          <a:noFill/>
+          <a:ln/>
+        </p:spPr>
+        <p:txBody>
+          <a:bodyPr wrap="square" rtlCol="0" anchor="ctr"/>
+          <a:lstStyle/>
+          <a:p>
+            <a:pPr marL="0" indent="0">
+              <a:buNone/>
+            </a:pPr>
+            <a:r>
+              <a:rPr lang="en-US" sz="1100" b="1" kern="0" spc="100" dirty="0">
+                <a:solidFill>
+                  <a:srgbClr val="CADCFC"/>
+                </a:solidFill>
+                <a:latin typeface="맑은 고딕" pitchFamily="34" charset="0"/>
+                <a:ea typeface="맑은 고딕" pitchFamily="34" charset="-122"/>
+                <a:cs typeface="맑은 고딕" pitchFamily="34" charset="-120"/>
+              </a:rPr>
+              <a:t>03  PROJECT — AK아이에스 3/3</a:t>
+            </a:r>
+            <a:endParaRPr lang="en-US" sz="1100" dirty="0"/>
+          </a:p>
+        </p:txBody>
+      </p:sp>
+      <p:sp>
+        <p:nvSpPr>
+          <p:cNvPr id="4" name="Text 2"/>
+          <p:cNvSpPr/>
+          <p:nvPr/>
+        </p:nvSpPr>
+        <p:spPr>
+          <a:xfrm>
+            <a:off x="548640" y="384048"/>
+            <a:ext cx="10058400" cy="502920"/>
+          </a:xfrm>
+          <a:prstGeom prst="rect">
+            <a:avLst/>
+          </a:prstGeom>
+          <a:noFill/>
+          <a:ln/>
+        </p:spPr>
+        <p:txBody>
+          <a:bodyPr wrap="square" rtlCol="0" anchor="ctr"/>
+          <a:lstStyle/>
+          <a:p>
+            <a:pPr marL="0" indent="0">
+              <a:buNone/>
+            </a:pPr>
+            <a:r>
+              <a:rPr lang="en-US" sz="2400" b="1" dirty="0">
+                <a:solidFill>
+                  <a:srgbClr val="FFFFFF"/>
+                </a:solidFill>
+                <a:latin typeface="맑은 고딕" pitchFamily="34" charset="0"/>
+                <a:ea typeface="맑은 고딕" pitchFamily="34" charset="-122"/>
+                <a:cs typeface="맑은 고딕" pitchFamily="34" charset="-120"/>
+              </a:rPr>
+              <a:t>대표 프로젝트</a:t>
+            </a:r>
+            <a:endParaRPr lang="en-US" sz="2400" dirty="0"/>
+          </a:p>
+        </p:txBody>
+      </p:sp>
+      <p:sp>
+        <p:nvSpPr>
+          <p:cNvPr id="5" name="Shape 3"/>
+          <p:cNvSpPr/>
+          <p:nvPr/>
+        </p:nvSpPr>
+        <p:spPr>
+          <a:xfrm>
+            <a:off x="2451050" y="1188720"/>
+            <a:ext cx="7289596" cy="5166360"/>
+          </a:xfrm>
+          <a:prstGeom prst="roundRect">
+            <a:avLst>
+              <a:gd name="adj" fmla="val 2099"/>
+            </a:avLst>
+          </a:prstGeom>
+          <a:solidFill>
+            <a:srgbClr val="F1F5FC"/>
+          </a:solidFill>
+          <a:ln w="12700">
+            <a:solidFill>
+              <a:srgbClr val="D8E3F5"/>
+            </a:solidFill>
+            <a:prstDash val="solid"/>
+          </a:ln>
+          <a:effectLst>
+            <a:outerShdw blurRad="76200" dist="25400" dir="5400000" algn="bl" rotWithShape="0">
+              <a:srgbClr val="1E2761">
+                <a:alpha val="12000"/>
+              </a:srgbClr>
+            </a:outerShdw>
+          </a:effectLst>
+        </p:spPr>
+        <p:txBody>
+          <a:bodyPr/>
+          <a:lstStyle/>
+          <a:p>
+            <a:endParaRPr lang="ko-KR" altLang="en-US"/>
+          </a:p>
+        </p:txBody>
+      </p:sp>
+      <p:sp>
+        <p:nvSpPr>
+          <p:cNvPr id="6" name="Shape 4"/>
+          <p:cNvSpPr/>
+          <p:nvPr/>
+        </p:nvSpPr>
+        <p:spPr>
+          <a:xfrm>
+            <a:off x="2451050" y="1188720"/>
+            <a:ext cx="7289596" cy="457200"/>
+          </a:xfrm>
+          <a:prstGeom prst="roundRect">
+            <a:avLst>
+              <a:gd name="adj" fmla="val 16000"/>
+            </a:avLst>
+          </a:prstGeom>
+          <a:solidFill>
+            <a:srgbClr val="1E2761"/>
+          </a:solidFill>
+          <a:ln/>
+        </p:spPr>
+        <p:txBody>
+          <a:bodyPr/>
+          <a:lstStyle/>
+          <a:p>
+            <a:endParaRPr lang="ko-KR" altLang="en-US"/>
+          </a:p>
+        </p:txBody>
+      </p:sp>
+      <p:sp>
+        <p:nvSpPr>
+          <p:cNvPr id="7" name="Shape 5"/>
+          <p:cNvSpPr/>
+          <p:nvPr/>
+        </p:nvSpPr>
+        <p:spPr>
+          <a:xfrm>
+            <a:off x="2451050" y="1417320"/>
+            <a:ext cx="7289596" cy="228600"/>
+          </a:xfrm>
+          <a:prstGeom prst="rect">
+            <a:avLst/>
+          </a:prstGeom>
+          <a:solidFill>
+            <a:srgbClr val="1E2761"/>
+          </a:solidFill>
+          <a:ln/>
+        </p:spPr>
+        <p:txBody>
+          <a:bodyPr/>
+          <a:lstStyle/>
+          <a:p>
+            <a:endParaRPr lang="ko-KR" altLang="en-US"/>
+          </a:p>
+        </p:txBody>
+      </p:sp>
+      <p:sp>
+        <p:nvSpPr>
+          <p:cNvPr id="8" name="Text 6"/>
+          <p:cNvSpPr/>
+          <p:nvPr/>
+        </p:nvSpPr>
+        <p:spPr>
+          <a:xfrm>
+            <a:off x="2633930" y="1188720"/>
+            <a:ext cx="6923836" cy="457200"/>
+          </a:xfrm>
+          <a:prstGeom prst="rect">
+            <a:avLst/>
+          </a:prstGeom>
+          <a:noFill/>
+          <a:ln/>
+        </p:spPr>
+        <p:txBody>
+          <a:bodyPr wrap="square" rtlCol="0" anchor="ctr"/>
+          <a:lstStyle/>
+          <a:p>
+            <a:pPr marL="0" indent="0">
+              <a:buNone/>
+            </a:pPr>
+            <a:r>
+              <a:rPr lang="en-US" sz="950" b="1" dirty="0">
+                <a:solidFill>
+                  <a:srgbClr val="CADCFC"/>
+                </a:solidFill>
+                <a:latin typeface="맑은 고딕" pitchFamily="34" charset="0"/>
+                <a:ea typeface="맑은 고딕" pitchFamily="34" charset="-122"/>
+                <a:cs typeface="맑은 고딕" pitchFamily="34" charset="-120"/>
+              </a:rPr>
+              <a:t>AK아이에스</a:t>
+            </a:r>
+            <a:endParaRPr lang="en-US" sz="950" dirty="0"/>
+          </a:p>
+        </p:txBody>
+      </p:sp>
+      <p:sp>
+        <p:nvSpPr>
+          <p:cNvPr id="9" name="Text 7"/>
+          <p:cNvSpPr/>
+          <p:nvPr/>
+        </p:nvSpPr>
+        <p:spPr>
+          <a:xfrm>
+            <a:off x="2633930" y="1188720"/>
+            <a:ext cx="6923836" cy="457200"/>
+          </a:xfrm>
+          <a:prstGeom prst="rect">
+            <a:avLst/>
+          </a:prstGeom>
+          <a:noFill/>
+          <a:ln/>
+        </p:spPr>
+        <p:txBody>
+          <a:bodyPr wrap="square" rtlCol="0" anchor="ctr"/>
+          <a:lstStyle/>
+          <a:p>
+            <a:pPr marL="0" indent="0" algn="r">
+              <a:buNone/>
+            </a:pPr>
+            <a:r>
+              <a:rPr lang="en-US" sz="950" b="1" dirty="0">
+                <a:solidFill>
+                  <a:srgbClr val="FFFFFF"/>
+                </a:solidFill>
+                <a:latin typeface="맑은 고딕" pitchFamily="34" charset="0"/>
+                <a:ea typeface="맑은 고딕" pitchFamily="34" charset="-122"/>
+                <a:cs typeface="맑은 고딕" pitchFamily="34" charset="-120"/>
+              </a:rPr>
+              <a:t>2024.01</a:t>
+            </a:r>
+            <a:endParaRPr lang="en-US" sz="950" dirty="0"/>
+          </a:p>
+        </p:txBody>
+      </p:sp>
+      <p:sp>
+        <p:nvSpPr>
+          <p:cNvPr id="10" name="Text 8"/>
+          <p:cNvSpPr/>
+          <p:nvPr/>
+        </p:nvSpPr>
+        <p:spPr>
+          <a:xfrm>
+            <a:off x="2679650" y="1783080"/>
+            <a:ext cx="6832396" cy="640080"/>
+          </a:xfrm>
+          <a:prstGeom prst="rect">
+            <a:avLst/>
+          </a:prstGeom>
+          <a:noFill/>
+          <a:ln/>
+        </p:spPr>
+        <p:txBody>
+          <a:bodyPr wrap="square" rtlCol="0" anchor="t"/>
+          <a:lstStyle/>
+          <a:p>
+            <a:pPr marL="0" indent="0">
+              <a:buNone/>
+            </a:pPr>
+            <a:r>
+              <a:rPr lang="en-US" sz="1400" b="1" dirty="0">
+                <a:solidFill>
+                  <a:srgbClr val="1E2761"/>
+                </a:solidFill>
+                <a:latin typeface="맑은 고딕" pitchFamily="34" charset="0"/>
+                <a:ea typeface="맑은 고딕" pitchFamily="34" charset="-122"/>
+                <a:cs typeface="맑은 고딕" pitchFamily="34" charset="-120"/>
+              </a:rPr>
+              <a:t>찜이벤트 트랜잭션 지연·오류 원인 진단</a:t>
+            </a:r>
+            <a:endParaRPr lang="en-US" sz="1400" dirty="0"/>
+          </a:p>
+        </p:txBody>
+      </p:sp>
+      <p:sp>
+        <p:nvSpPr>
+          <p:cNvPr id="11" name="Text 9"/>
+          <p:cNvSpPr/>
+          <p:nvPr/>
+        </p:nvSpPr>
+        <p:spPr>
+          <a:xfrm>
+            <a:off x="2679650" y="2514600"/>
+            <a:ext cx="6832396" cy="3429000"/>
+          </a:xfrm>
+          <a:prstGeom prst="rect">
+            <a:avLst/>
+          </a:prstGeom>
+          <a:noFill/>
+          <a:ln/>
+        </p:spPr>
+        <p:txBody>
+          <a:bodyPr wrap="square" rtlCol="0" anchor="t"/>
+          <a:lstStyle/>
+          <a:p>
+            <a:pPr marL="342900" indent="-342900">
+              <a:spcAft>
+                <a:spcPts val="900"/>
+              </a:spcAft>
+              <a:buSzPct val="100000"/>
+              <a:buChar char="▪"/>
+            </a:pPr>
+            <a:r>
+              <a:rPr lang="en-US" sz="1000" dirty="0">
+                <a:solidFill>
+                  <a:srgbClr val="1A1A2E"/>
+                </a:solidFill>
+                <a:latin typeface="맑은 고딕" pitchFamily="34" charset="0"/>
+                <a:ea typeface="맑은 고딕" pitchFamily="34" charset="-122"/>
+                <a:cs typeface="맑은 고딕" pitchFamily="34" charset="-120"/>
+              </a:rPr>
+              <a:t>APM 도구로 7개 업무 영역의 응답 지연·오류 트랜잭션을 먼저 넓게 스크리닝하고, 스레드 분석 도구로 원인을 정밀 추적하는 2단계 진단 체계 설계</a:t>
+            </a:r>
+            <a:endParaRPr lang="en-US" sz="1000" dirty="0"/>
+          </a:p>
+          <a:p>
+            <a:pPr marL="342900" indent="-342900">
+              <a:spcAft>
+                <a:spcPts val="900"/>
+              </a:spcAft>
+              <a:buSzPct val="100000"/>
+              <a:buChar char="▪"/>
+            </a:pPr>
+            <a:r>
+              <a:rPr lang="en-US" sz="1000" dirty="0">
+                <a:solidFill>
+                  <a:srgbClr val="1A1A2E"/>
+                </a:solidFill>
+                <a:latin typeface="맑은 고딕" pitchFamily="34" charset="0"/>
+                <a:ea typeface="맑은 고딕" pitchFamily="34" charset="-122"/>
+                <a:cs typeface="맑은 고딕" pitchFamily="34" charset="-120"/>
+              </a:rPr>
+              <a:t>오류 로그를 유형별로 분류 — 클라이언트 이탈, 외부 API 응답 시간 초과, DB 데이터 제약 위반 등 패턴 정리</a:t>
+            </a:r>
+            <a:endParaRPr lang="en-US" sz="1000" dirty="0"/>
+          </a:p>
+          <a:p>
+            <a:pPr marL="342900" indent="-342900">
+              <a:spcAft>
+                <a:spcPts val="900"/>
+              </a:spcAft>
+              <a:buSzPct val="100000"/>
+              <a:buChar char="▪"/>
+            </a:pPr>
+            <a:r>
+              <a:rPr lang="en-US" sz="1000" dirty="0">
+                <a:solidFill>
+                  <a:srgbClr val="1A1A2E"/>
+                </a:solidFill>
+                <a:latin typeface="맑은 고딕" pitchFamily="34" charset="0"/>
+                <a:ea typeface="맑은 고딕" pitchFamily="34" charset="-122"/>
+                <a:cs typeface="맑은 고딕" pitchFamily="34" charset="-120"/>
+              </a:rPr>
+              <a:t>지연 트랜잭션의 실행 상태를 추적한 결과 대부분 외부 응답을 기다리는 상태로 확인, 자체 서버·DB 처리 지연이 아닌 외부 연동 API 응답 지연으로 원인 특정</a:t>
+            </a:r>
+            <a:endParaRPr lang="en-US" sz="1000" dirty="0"/>
+          </a:p>
+          <a:p>
+            <a:pPr marL="342900" indent="-342900">
+              <a:spcAft>
+                <a:spcPts val="900"/>
+              </a:spcAft>
+              <a:buSzPct val="100000"/>
+              <a:buChar char="▪"/>
+            </a:pPr>
+            <a:r>
+              <a:rPr lang="en-US" sz="1000" dirty="0">
+                <a:solidFill>
+                  <a:srgbClr val="1A1A2E"/>
+                </a:solidFill>
+                <a:latin typeface="맑은 고딕" pitchFamily="34" charset="0"/>
+                <a:ea typeface="맑은 고딕" pitchFamily="34" charset="-122"/>
+                <a:cs typeface="맑은 고딕" pitchFamily="34" charset="-120"/>
+              </a:rPr>
+              <a:t>업무별로 흩어져 있던 원인불명 이슈를 공통 원인(외부 API 응답 지연)으로 통합 진단</a:t>
+            </a:r>
+            <a:endParaRPr lang="en-US" sz="1000" dirty="0"/>
+          </a:p>
+        </p:txBody>
+      </p:sp>
+      <p:sp>
+        <p:nvSpPr>
+          <p:cNvPr id="12" name="Text 10"/>
+          <p:cNvSpPr/>
+          <p:nvPr/>
+        </p:nvSpPr>
+        <p:spPr>
+          <a:xfrm>
+            <a:off x="2679650" y="5852160"/>
+            <a:ext cx="6832396" cy="411480"/>
+          </a:xfrm>
+          <a:prstGeom prst="rect">
+            <a:avLst/>
+          </a:prstGeom>
+          <a:noFill/>
+          <a:ln/>
+        </p:spPr>
+        <p:txBody>
+          <a:bodyPr wrap="square" rtlCol="0" anchor="ctr"/>
+          <a:lstStyle/>
+          <a:p>
+            <a:pPr marL="0" indent="0">
+              <a:buNone/>
+            </a:pPr>
+            <a:r>
+              <a:rPr lang="en-US" sz="950" b="1" dirty="0">
+                <a:solidFill>
+                  <a:srgbClr val="1E2761"/>
+                </a:solidFill>
+                <a:latin typeface="맑은 고딕" pitchFamily="34" charset="0"/>
+                <a:ea typeface="맑은 고딕" pitchFamily="34" charset="-122"/>
+                <a:cs typeface="맑은 고딕" pitchFamily="34" charset="-120"/>
+              </a:rPr>
+              <a:t>결과 — 7개 업무 영역 지연 원인 공통 특정, 예약·멤버십 시스템은 트래픽 제한 조치로 대응</a:t>
+            </a:r>
+            <a:endParaRPr lang="en-US" sz="950" dirty="0"/>
+          </a:p>
+        </p:txBody>
+      </p:sp>
+    </p:spTree>
+  </p:cSld>
+  <p:clrMapOvr>
+    <a:masterClrMapping/>
+  </p:clrMapOvr>
+</p:sld>
+</file>
+
 <file path=ppt/slides/slide2.xml><?xml version="1.0" encoding="utf-8"?>
 <p:sld xmlns:a="http://schemas.openxmlformats.org/drawingml/2006/main" xmlns:r="http://schemas.openxmlformats.org/officeDocument/2006/relationships" xmlns:p="http://schemas.openxmlformats.org/presentationml/2006/main">
   <p:cSld name="Slide 2">
@@ -6593,7 +7091,7 @@
                 <a:ea typeface="맑은 고딕" pitchFamily="34" charset="-122"/>
                 <a:cs typeface="맑은 고딕" pitchFamily="34" charset="-120"/>
               </a:rPr>
-              <a:t>03  PROJECT — AK아이에스 1/2</a:t>
+              <a:t>03  PROJECT — AK아이에스 1/3</a:t>
             </a:r>
             <a:endParaRPr lang="en-US" sz="1100" dirty="0"/>
           </a:p>
@@ -7745,7 +8243,7 @@
                 <a:ea typeface="맑은 고딕" pitchFamily="34" charset="-122"/>
                 <a:cs typeface="맑은 고딕" pitchFamily="34" charset="-120"/>
               </a:rPr>
-              <a:t>03  PROJECT — AK아이에스 2/2</a:t>
+              <a:t>03  PROJECT — AK아이에스 2/3</a:t>
             </a:r>
             <a:endParaRPr lang="en-US" sz="1100" dirty="0"/>
           </a:p>

</xml_diff>